<commit_message>
adds authentication methods to http lesson
</commit_message>
<xml_diff>
--- a/Python/Lesson 10 - HTTP and APIs/HTTP and APIs.pptx
+++ b/Python/Lesson 10 - HTTP and APIs/HTTP and APIs.pptx
@@ -5,7 +5,7 @@
     <p:sldMasterId id="2147483660" r:id="rId1"/>
   </p:sldMasterIdLst>
   <p:notesMasterIdLst>
-    <p:notesMasterId r:id="rId16"/>
+    <p:notesMasterId r:id="rId25"/>
   </p:notesMasterIdLst>
   <p:sldIdLst>
     <p:sldId id="256" r:id="rId2"/>
@@ -20,8 +20,17 @@
     <p:sldId id="1278" r:id="rId11"/>
     <p:sldId id="1279" r:id="rId12"/>
     <p:sldId id="1273" r:id="rId13"/>
-    <p:sldId id="1274" r:id="rId14"/>
-    <p:sldId id="284" r:id="rId15"/>
+    <p:sldId id="1287" r:id="rId14"/>
+    <p:sldId id="1288" r:id="rId15"/>
+    <p:sldId id="1286" r:id="rId16"/>
+    <p:sldId id="1274" r:id="rId17"/>
+    <p:sldId id="1280" r:id="rId18"/>
+    <p:sldId id="1281" r:id="rId19"/>
+    <p:sldId id="1284" r:id="rId20"/>
+    <p:sldId id="1282" r:id="rId21"/>
+    <p:sldId id="1283" r:id="rId22"/>
+    <p:sldId id="1285" r:id="rId23"/>
+    <p:sldId id="284" r:id="rId24"/>
   </p:sldIdLst>
   <p:sldSz cx="12192000" cy="6858000"/>
   <p:notesSz cx="6858000" cy="9144000"/>
@@ -210,7 +219,7 @@
           <a:p>
             <a:fld id="{7D2F5B96-EC90-4B10-91AC-E32DA21E81E1}" type="datetimeFigureOut">
               <a:rPr lang="en-US" smtClean="0"/>
-              <a:t>22-Jun-26</a:t>
+              <a:t>23-Jun-26</a:t>
             </a:fld>
             <a:endParaRPr lang="en-US"/>
           </a:p>
@@ -564,6 +573,553 @@
 </p:notes>
 </file>
 
+<file path=ppt/notesSlides/notesSlide10.xml><?xml version="1.0" encoding="utf-8"?>
+<p:notes xmlns:a="http://schemas.openxmlformats.org/drawingml/2006/main" xmlns:r="http://schemas.openxmlformats.org/officeDocument/2006/relationships" xmlns:p="http://schemas.openxmlformats.org/presentationml/2006/main">
+  <p:cSld>
+    <p:spTree>
+      <p:nvGrpSpPr>
+        <p:cNvPr id="1" name=""/>
+        <p:cNvGrpSpPr/>
+        <p:nvPr/>
+      </p:nvGrpSpPr>
+      <p:grpSpPr>
+        <a:xfrm>
+          <a:off x="0" y="0"/>
+          <a:ext cx="0" cy="0"/>
+          <a:chOff x="0" y="0"/>
+          <a:chExt cx="0" cy="0"/>
+        </a:xfrm>
+      </p:grpSpPr>
+      <p:sp>
+        <p:nvSpPr>
+          <p:cNvPr id="2" name="Slide Image Placeholder 1"/>
+          <p:cNvSpPr>
+            <a:spLocks noGrp="1" noRot="1" noChangeAspect="1"/>
+          </p:cNvSpPr>
+          <p:nvPr>
+            <p:ph type="sldImg"/>
+          </p:nvPr>
+        </p:nvSpPr>
+        <p:spPr/>
+      </p:sp>
+      <p:sp>
+        <p:nvSpPr>
+          <p:cNvPr id="3" name="Notes Placeholder 2"/>
+          <p:cNvSpPr>
+            <a:spLocks noGrp="1"/>
+          </p:cNvSpPr>
+          <p:nvPr>
+            <p:ph type="body" idx="1"/>
+          </p:nvPr>
+        </p:nvSpPr>
+        <p:spPr/>
+        <p:txBody>
+          <a:bodyPr/>
+          <a:lstStyle/>
+          <a:p>
+            <a:r>
+              <a:rPr lang="en-US" dirty="0"/>
+              <a:t>Pros:</a:t>
+            </a:r>
+          </a:p>
+          <a:p>
+            <a:pPr marL="171450" indent="-171450">
+              <a:buFontTx/>
+              <a:buChar char="-"/>
+            </a:pPr>
+            <a:r>
+              <a:rPr lang="en-US" dirty="0"/>
+              <a:t>Simple</a:t>
+            </a:r>
+          </a:p>
+          <a:p>
+            <a:pPr marL="171450" indent="-171450">
+              <a:buFontTx/>
+              <a:buChar char="-"/>
+            </a:pPr>
+            <a:r>
+              <a:rPr lang="en-US" dirty="0"/>
+              <a:t>Stateless</a:t>
+            </a:r>
+          </a:p>
+          <a:p>
+            <a:pPr marL="171450" indent="-171450">
+              <a:buFontTx/>
+              <a:buChar char="-"/>
+            </a:pPr>
+            <a:r>
+              <a:rPr lang="en-US" dirty="0"/>
+              <a:t>Can auth 3rd parties</a:t>
+            </a:r>
+          </a:p>
+          <a:p>
+            <a:pPr marL="0" indent="0">
+              <a:buFontTx/>
+              <a:buNone/>
+            </a:pPr>
+            <a:endParaRPr lang="en-US" dirty="0"/>
+          </a:p>
+          <a:p>
+            <a:pPr marL="0" indent="0">
+              <a:buFontTx/>
+              <a:buNone/>
+            </a:pPr>
+            <a:r>
+              <a:rPr lang="en-US" dirty="0"/>
+              <a:t>Cons;</a:t>
+            </a:r>
+          </a:p>
+          <a:p>
+            <a:pPr marL="171450" indent="-171450">
+              <a:buFontTx/>
+              <a:buChar char="-"/>
+            </a:pPr>
+            <a:r>
+              <a:rPr lang="en-US" dirty="0"/>
+              <a:t>Hard to rotate keys</a:t>
+            </a:r>
+          </a:p>
+          <a:p>
+            <a:pPr marL="171450" indent="-171450">
+              <a:buFontTx/>
+              <a:buChar char="-"/>
+            </a:pPr>
+            <a:r>
+              <a:rPr lang="en-US" dirty="0"/>
+              <a:t>Generally not user-specific</a:t>
+            </a:r>
+          </a:p>
+          <a:p>
+            <a:endParaRPr lang="en-US" dirty="0"/>
+          </a:p>
+        </p:txBody>
+      </p:sp>
+      <p:sp>
+        <p:nvSpPr>
+          <p:cNvPr id="4" name="Slide Number Placeholder 3"/>
+          <p:cNvSpPr>
+            <a:spLocks noGrp="1"/>
+          </p:cNvSpPr>
+          <p:nvPr>
+            <p:ph type="sldNum" sz="quarter" idx="5"/>
+          </p:nvPr>
+        </p:nvSpPr>
+        <p:spPr/>
+        <p:txBody>
+          <a:bodyPr/>
+          <a:lstStyle/>
+          <a:p>
+            <a:fld id="{BE457D5F-ED05-449E-97D0-205DAB987247}" type="slidenum">
+              <a:rPr lang="en-US" smtClean="0"/>
+              <a:t>18</a:t>
+            </a:fld>
+            <a:endParaRPr lang="en-US"/>
+          </a:p>
+        </p:txBody>
+      </p:sp>
+    </p:spTree>
+    <p:extLst>
+      <p:ext uri="{BB962C8B-B14F-4D97-AF65-F5344CB8AC3E}">
+        <p14:creationId xmlns:p14="http://schemas.microsoft.com/office/powerpoint/2010/main" val="1253076170"/>
+      </p:ext>
+    </p:extLst>
+  </p:cSld>
+  <p:clrMapOvr>
+    <a:masterClrMapping/>
+  </p:clrMapOvr>
+</p:notes>
+</file>
+
+<file path=ppt/notesSlides/notesSlide11.xml><?xml version="1.0" encoding="utf-8"?>
+<p:notes xmlns:a="http://schemas.openxmlformats.org/drawingml/2006/main" xmlns:r="http://schemas.openxmlformats.org/officeDocument/2006/relationships" xmlns:p="http://schemas.openxmlformats.org/presentationml/2006/main">
+  <p:cSld>
+    <p:spTree>
+      <p:nvGrpSpPr>
+        <p:cNvPr id="1" name=""/>
+        <p:cNvGrpSpPr/>
+        <p:nvPr/>
+      </p:nvGrpSpPr>
+      <p:grpSpPr>
+        <a:xfrm>
+          <a:off x="0" y="0"/>
+          <a:ext cx="0" cy="0"/>
+          <a:chOff x="0" y="0"/>
+          <a:chExt cx="0" cy="0"/>
+        </a:xfrm>
+      </p:grpSpPr>
+      <p:sp>
+        <p:nvSpPr>
+          <p:cNvPr id="2" name="Slide Image Placeholder 1"/>
+          <p:cNvSpPr>
+            <a:spLocks noGrp="1" noRot="1" noChangeAspect="1"/>
+          </p:cNvSpPr>
+          <p:nvPr>
+            <p:ph type="sldImg"/>
+          </p:nvPr>
+        </p:nvSpPr>
+        <p:spPr/>
+      </p:sp>
+      <p:sp>
+        <p:nvSpPr>
+          <p:cNvPr id="3" name="Notes Placeholder 2"/>
+          <p:cNvSpPr>
+            <a:spLocks noGrp="1"/>
+          </p:cNvSpPr>
+          <p:nvPr>
+            <p:ph type="body" idx="1"/>
+          </p:nvPr>
+        </p:nvSpPr>
+        <p:spPr/>
+        <p:txBody>
+          <a:bodyPr/>
+          <a:lstStyle/>
+          <a:p>
+            <a:r>
+              <a:rPr lang="en-US" dirty="0"/>
+              <a:t>Pros:</a:t>
+            </a:r>
+          </a:p>
+          <a:p>
+            <a:pPr marL="171450" indent="-171450">
+              <a:buFontTx/>
+              <a:buChar char="-"/>
+            </a:pPr>
+            <a:r>
+              <a:rPr lang="en-US" dirty="0"/>
+              <a:t>Simple</a:t>
+            </a:r>
+          </a:p>
+          <a:p>
+            <a:pPr marL="171450" indent="-171450">
+              <a:buFontTx/>
+              <a:buChar char="-"/>
+            </a:pPr>
+            <a:r>
+              <a:rPr lang="en-US" dirty="0"/>
+              <a:t>User-specific</a:t>
+            </a:r>
+          </a:p>
+          <a:p>
+            <a:pPr marL="0" indent="0">
+              <a:buFontTx/>
+              <a:buNone/>
+            </a:pPr>
+            <a:endParaRPr lang="en-US" dirty="0"/>
+          </a:p>
+          <a:p>
+            <a:pPr marL="0" indent="0">
+              <a:buFontTx/>
+              <a:buNone/>
+            </a:pPr>
+            <a:r>
+              <a:rPr lang="en-US" dirty="0"/>
+              <a:t>Cons:</a:t>
+            </a:r>
+          </a:p>
+          <a:p>
+            <a:pPr marL="171450" indent="-171450">
+              <a:buFontTx/>
+              <a:buChar char="-"/>
+            </a:pPr>
+            <a:r>
+              <a:rPr lang="en-US" dirty="0"/>
+              <a:t>Stateful</a:t>
+            </a:r>
+          </a:p>
+          <a:p>
+            <a:pPr marL="171450" indent="-171450">
+              <a:buFontTx/>
+              <a:buChar char="-"/>
+            </a:pPr>
+            <a:r>
+              <a:rPr lang="en-US" dirty="0"/>
+              <a:t>Cannot auth 3rd parties</a:t>
+            </a:r>
+          </a:p>
+          <a:p>
+            <a:endParaRPr lang="en-US" dirty="0"/>
+          </a:p>
+        </p:txBody>
+      </p:sp>
+      <p:sp>
+        <p:nvSpPr>
+          <p:cNvPr id="4" name="Slide Number Placeholder 3"/>
+          <p:cNvSpPr>
+            <a:spLocks noGrp="1"/>
+          </p:cNvSpPr>
+          <p:nvPr>
+            <p:ph type="sldNum" sz="quarter" idx="5"/>
+          </p:nvPr>
+        </p:nvSpPr>
+        <p:spPr/>
+        <p:txBody>
+          <a:bodyPr/>
+          <a:lstStyle/>
+          <a:p>
+            <a:fld id="{BE457D5F-ED05-449E-97D0-205DAB987247}" type="slidenum">
+              <a:rPr lang="en-US" smtClean="0"/>
+              <a:t>19</a:t>
+            </a:fld>
+            <a:endParaRPr lang="en-US"/>
+          </a:p>
+        </p:txBody>
+      </p:sp>
+    </p:spTree>
+    <p:extLst>
+      <p:ext uri="{BB962C8B-B14F-4D97-AF65-F5344CB8AC3E}">
+        <p14:creationId xmlns:p14="http://schemas.microsoft.com/office/powerpoint/2010/main" val="3830640556"/>
+      </p:ext>
+    </p:extLst>
+  </p:cSld>
+  <p:clrMapOvr>
+    <a:masterClrMapping/>
+  </p:clrMapOvr>
+</p:notes>
+</file>
+
+<file path=ppt/notesSlides/notesSlide12.xml><?xml version="1.0" encoding="utf-8"?>
+<p:notes xmlns:a="http://schemas.openxmlformats.org/drawingml/2006/main" xmlns:r="http://schemas.openxmlformats.org/officeDocument/2006/relationships" xmlns:p="http://schemas.openxmlformats.org/presentationml/2006/main">
+  <p:cSld>
+    <p:spTree>
+      <p:nvGrpSpPr>
+        <p:cNvPr id="1" name=""/>
+        <p:cNvGrpSpPr/>
+        <p:nvPr/>
+      </p:nvGrpSpPr>
+      <p:grpSpPr>
+        <a:xfrm>
+          <a:off x="0" y="0"/>
+          <a:ext cx="0" cy="0"/>
+          <a:chOff x="0" y="0"/>
+          <a:chExt cx="0" cy="0"/>
+        </a:xfrm>
+      </p:grpSpPr>
+      <p:sp>
+        <p:nvSpPr>
+          <p:cNvPr id="2" name="Slide Image Placeholder 1"/>
+          <p:cNvSpPr>
+            <a:spLocks noGrp="1" noRot="1" noChangeAspect="1"/>
+          </p:cNvSpPr>
+          <p:nvPr>
+            <p:ph type="sldImg"/>
+          </p:nvPr>
+        </p:nvSpPr>
+        <p:spPr/>
+      </p:sp>
+      <p:sp>
+        <p:nvSpPr>
+          <p:cNvPr id="3" name="Notes Placeholder 2"/>
+          <p:cNvSpPr>
+            <a:spLocks noGrp="1"/>
+          </p:cNvSpPr>
+          <p:nvPr>
+            <p:ph type="body" idx="1"/>
+          </p:nvPr>
+        </p:nvSpPr>
+        <p:spPr/>
+        <p:txBody>
+          <a:bodyPr/>
+          <a:lstStyle/>
+          <a:p>
+            <a:r>
+              <a:rPr lang="en-US" dirty="0"/>
+              <a:t>Pros:</a:t>
+            </a:r>
+          </a:p>
+          <a:p>
+            <a:pPr marL="171450" indent="-171450">
+              <a:buFontTx/>
+              <a:buChar char="-"/>
+            </a:pPr>
+            <a:r>
+              <a:rPr lang="en-US" dirty="0"/>
+              <a:t>Limited scope / time</a:t>
+            </a:r>
+          </a:p>
+          <a:p>
+            <a:pPr marL="171450" indent="-171450">
+              <a:buFontTx/>
+              <a:buChar char="-"/>
+            </a:pPr>
+            <a:r>
+              <a:rPr lang="en-US" dirty="0"/>
+              <a:t>User-specific</a:t>
+            </a:r>
+          </a:p>
+          <a:p>
+            <a:pPr marL="171450" indent="-171450">
+              <a:buFontTx/>
+              <a:buChar char="-"/>
+            </a:pPr>
+            <a:r>
+              <a:rPr lang="en-US" dirty="0"/>
+              <a:t>Can auth 3rd parties</a:t>
+            </a:r>
+          </a:p>
+          <a:p>
+            <a:pPr marL="0" indent="0">
+              <a:buFontTx/>
+              <a:buNone/>
+            </a:pPr>
+            <a:endParaRPr lang="en-US" dirty="0"/>
+          </a:p>
+          <a:p>
+            <a:pPr marL="0" indent="0">
+              <a:buFontTx/>
+              <a:buNone/>
+            </a:pPr>
+            <a:r>
+              <a:rPr lang="en-US" dirty="0"/>
+              <a:t>Cons:</a:t>
+            </a:r>
+          </a:p>
+          <a:p>
+            <a:pPr marL="171450" indent="-171450">
+              <a:buFontTx/>
+              <a:buChar char="-"/>
+            </a:pPr>
+            <a:r>
+              <a:rPr lang="en-US" dirty="0"/>
+              <a:t>Complexity</a:t>
+            </a:r>
+          </a:p>
+          <a:p>
+            <a:endParaRPr lang="en-US" dirty="0"/>
+          </a:p>
+          <a:p>
+            <a:endParaRPr lang="en-US" dirty="0"/>
+          </a:p>
+          <a:p>
+            <a:r>
+              <a:rPr lang="en-US" dirty="0"/>
+              <a:t>https://www.c-sharpcorner.com/article/a-net-developers-complete-guide-to-choose-right-authentication-from-basic-aut/</a:t>
+            </a:r>
+          </a:p>
+        </p:txBody>
+      </p:sp>
+      <p:sp>
+        <p:nvSpPr>
+          <p:cNvPr id="4" name="Slide Number Placeholder 3"/>
+          <p:cNvSpPr>
+            <a:spLocks noGrp="1"/>
+          </p:cNvSpPr>
+          <p:nvPr>
+            <p:ph type="sldNum" sz="quarter" idx="5"/>
+          </p:nvPr>
+        </p:nvSpPr>
+        <p:spPr/>
+        <p:txBody>
+          <a:bodyPr/>
+          <a:lstStyle/>
+          <a:p>
+            <a:fld id="{BE457D5F-ED05-449E-97D0-205DAB987247}" type="slidenum">
+              <a:rPr lang="en-US" smtClean="0"/>
+              <a:t>20</a:t>
+            </a:fld>
+            <a:endParaRPr lang="en-US"/>
+          </a:p>
+        </p:txBody>
+      </p:sp>
+    </p:spTree>
+    <p:extLst>
+      <p:ext uri="{BB962C8B-B14F-4D97-AF65-F5344CB8AC3E}">
+        <p14:creationId xmlns:p14="http://schemas.microsoft.com/office/powerpoint/2010/main" val="1610383274"/>
+      </p:ext>
+    </p:extLst>
+  </p:cSld>
+  <p:clrMapOvr>
+    <a:masterClrMapping/>
+  </p:clrMapOvr>
+</p:notes>
+</file>
+
+<file path=ppt/notesSlides/notesSlide13.xml><?xml version="1.0" encoding="utf-8"?>
+<p:notes xmlns:a="http://schemas.openxmlformats.org/drawingml/2006/main" xmlns:r="http://schemas.openxmlformats.org/officeDocument/2006/relationships" xmlns:p="http://schemas.openxmlformats.org/presentationml/2006/main">
+  <p:cSld>
+    <p:spTree>
+      <p:nvGrpSpPr>
+        <p:cNvPr id="1" name=""/>
+        <p:cNvGrpSpPr/>
+        <p:nvPr/>
+      </p:nvGrpSpPr>
+      <p:grpSpPr>
+        <a:xfrm>
+          <a:off x="0" y="0"/>
+          <a:ext cx="0" cy="0"/>
+          <a:chOff x="0" y="0"/>
+          <a:chExt cx="0" cy="0"/>
+        </a:xfrm>
+      </p:grpSpPr>
+      <p:sp>
+        <p:nvSpPr>
+          <p:cNvPr id="2" name="Slide Image Placeholder 1"/>
+          <p:cNvSpPr>
+            <a:spLocks noGrp="1" noRot="1" noChangeAspect="1"/>
+          </p:cNvSpPr>
+          <p:nvPr>
+            <p:ph type="sldImg"/>
+          </p:nvPr>
+        </p:nvSpPr>
+        <p:spPr/>
+      </p:sp>
+      <p:sp>
+        <p:nvSpPr>
+          <p:cNvPr id="3" name="Notes Placeholder 2"/>
+          <p:cNvSpPr>
+            <a:spLocks noGrp="1"/>
+          </p:cNvSpPr>
+          <p:nvPr>
+            <p:ph type="body" idx="1"/>
+          </p:nvPr>
+        </p:nvSpPr>
+        <p:spPr/>
+        <p:txBody>
+          <a:bodyPr/>
+          <a:lstStyle/>
+          <a:p>
+            <a:r>
+              <a:rPr lang="en-US" dirty="0"/>
+              <a:t>https://medium.com/@reddyyashu20/beginners-guide-to-fastapi-openai-chatgpt-api-integration-50a0c3b8571e</a:t>
+            </a:r>
+          </a:p>
+        </p:txBody>
+      </p:sp>
+      <p:sp>
+        <p:nvSpPr>
+          <p:cNvPr id="4" name="Slide Number Placeholder 3"/>
+          <p:cNvSpPr>
+            <a:spLocks noGrp="1"/>
+          </p:cNvSpPr>
+          <p:nvPr>
+            <p:ph type="sldNum" sz="quarter" idx="5"/>
+          </p:nvPr>
+        </p:nvSpPr>
+        <p:spPr/>
+        <p:txBody>
+          <a:bodyPr/>
+          <a:lstStyle/>
+          <a:p>
+            <a:fld id="{BE457D5F-ED05-449E-97D0-205DAB987247}" type="slidenum">
+              <a:rPr lang="en-US" smtClean="0"/>
+              <a:t>21</a:t>
+            </a:fld>
+            <a:endParaRPr lang="en-US"/>
+          </a:p>
+        </p:txBody>
+      </p:sp>
+    </p:spTree>
+    <p:extLst>
+      <p:ext uri="{BB962C8B-B14F-4D97-AF65-F5344CB8AC3E}">
+        <p14:creationId xmlns:p14="http://schemas.microsoft.com/office/powerpoint/2010/main" val="4233136488"/>
+      </p:ext>
+    </p:extLst>
+  </p:cSld>
+  <p:clrMapOvr>
+    <a:masterClrMapping/>
+  </p:clrMapOvr>
+</p:notes>
+</file>
+
 <file path=ppt/notesSlides/notesSlide2.xml><?xml version="1.0" encoding="utf-8"?>
 <p:notes xmlns:a="http://schemas.openxmlformats.org/drawingml/2006/main" xmlns:r="http://schemas.openxmlformats.org/officeDocument/2006/relationships" xmlns:p="http://schemas.openxmlformats.org/presentationml/2006/main">
   <p:cSld>
@@ -1141,6 +1697,298 @@
     <p:extLst>
       <p:ext uri="{BB962C8B-B14F-4D97-AF65-F5344CB8AC3E}">
         <p14:creationId xmlns:p14="http://schemas.microsoft.com/office/powerpoint/2010/main" val="2843298489"/>
+      </p:ext>
+    </p:extLst>
+  </p:cSld>
+  <p:clrMapOvr>
+    <a:masterClrMapping/>
+  </p:clrMapOvr>
+</p:notes>
+</file>
+
+<file path=ppt/notesSlides/notesSlide8.xml><?xml version="1.0" encoding="utf-8"?>
+<p:notes xmlns:a="http://schemas.openxmlformats.org/drawingml/2006/main" xmlns:r="http://schemas.openxmlformats.org/officeDocument/2006/relationships" xmlns:p="http://schemas.openxmlformats.org/presentationml/2006/main">
+  <p:cSld>
+    <p:spTree>
+      <p:nvGrpSpPr>
+        <p:cNvPr id="1" name="">
+          <a:extLst>
+            <a:ext uri="{FF2B5EF4-FFF2-40B4-BE49-F238E27FC236}">
+              <a16:creationId xmlns:a16="http://schemas.microsoft.com/office/drawing/2014/main" id="{536F02DE-DFC8-D451-2546-4F218A2A0898}"/>
+            </a:ext>
+          </a:extLst>
+        </p:cNvPr>
+        <p:cNvGrpSpPr/>
+        <p:nvPr/>
+      </p:nvGrpSpPr>
+      <p:grpSpPr>
+        <a:xfrm>
+          <a:off x="0" y="0"/>
+          <a:ext cx="0" cy="0"/>
+          <a:chOff x="0" y="0"/>
+          <a:chExt cx="0" cy="0"/>
+        </a:xfrm>
+      </p:grpSpPr>
+      <p:sp>
+        <p:nvSpPr>
+          <p:cNvPr id="2" name="Slide Image Placeholder 1">
+            <a:extLst>
+              <a:ext uri="{FF2B5EF4-FFF2-40B4-BE49-F238E27FC236}">
+                <a16:creationId xmlns:a16="http://schemas.microsoft.com/office/drawing/2014/main" id="{8880FDF5-D189-423F-0586-8EDEC365E844}"/>
+              </a:ext>
+            </a:extLst>
+          </p:cNvPr>
+          <p:cNvSpPr>
+            <a:spLocks noGrp="1" noRot="1" noChangeAspect="1"/>
+          </p:cNvSpPr>
+          <p:nvPr>
+            <p:ph type="sldImg"/>
+          </p:nvPr>
+        </p:nvSpPr>
+        <p:spPr/>
+      </p:sp>
+      <p:sp>
+        <p:nvSpPr>
+          <p:cNvPr id="3" name="Notes Placeholder 2">
+            <a:extLst>
+              <a:ext uri="{FF2B5EF4-FFF2-40B4-BE49-F238E27FC236}">
+                <a16:creationId xmlns:a16="http://schemas.microsoft.com/office/drawing/2014/main" id="{2137CF05-2E6F-D07E-AEDC-74BAC8A8C9F8}"/>
+              </a:ext>
+            </a:extLst>
+          </p:cNvPr>
+          <p:cNvSpPr>
+            <a:spLocks noGrp="1"/>
+          </p:cNvSpPr>
+          <p:nvPr>
+            <p:ph type="body" idx="1"/>
+          </p:nvPr>
+        </p:nvSpPr>
+        <p:spPr/>
+        <p:txBody>
+          <a:bodyPr/>
+          <a:lstStyle/>
+          <a:p>
+            <a:r>
+              <a:rPr lang="en-US" dirty="0"/>
+              <a:t>GET /test HTTP/1.1</a:t>
+            </a:r>
+          </a:p>
+          <a:p>
+            <a:r>
+              <a:rPr lang="en-US" dirty="0"/>
+              <a:t>Host: example.com</a:t>
+            </a:r>
+          </a:p>
+          <a:p>
+            <a:r>
+              <a:rPr lang="en-US" dirty="0"/>
+              <a:t>Accept: */*</a:t>
+            </a:r>
+          </a:p>
+          <a:p>
+            <a:endParaRPr lang="en-US" dirty="0"/>
+          </a:p>
+          <a:p>
+            <a:r>
+              <a:rPr lang="en-US" dirty="0"/>
+              <a:t>{"param"="hello"}</a:t>
+            </a:r>
+          </a:p>
+          <a:p>
+            <a:endParaRPr lang="en-US" dirty="0"/>
+          </a:p>
+          <a:p>
+            <a:endParaRPr lang="en-US" dirty="0"/>
+          </a:p>
+        </p:txBody>
+      </p:sp>
+      <p:sp>
+        <p:nvSpPr>
+          <p:cNvPr id="4" name="Slide Number Placeholder 3">
+            <a:extLst>
+              <a:ext uri="{FF2B5EF4-FFF2-40B4-BE49-F238E27FC236}">
+                <a16:creationId xmlns:a16="http://schemas.microsoft.com/office/drawing/2014/main" id="{9D9E26E9-E2D3-BF05-C6B9-D2B8990F6D7D}"/>
+              </a:ext>
+            </a:extLst>
+          </p:cNvPr>
+          <p:cNvSpPr>
+            <a:spLocks noGrp="1"/>
+          </p:cNvSpPr>
+          <p:nvPr>
+            <p:ph type="sldNum" sz="quarter" idx="5"/>
+          </p:nvPr>
+        </p:nvSpPr>
+        <p:spPr/>
+        <p:txBody>
+          <a:bodyPr/>
+          <a:lstStyle/>
+          <a:p>
+            <a:fld id="{BE457D5F-ED05-449E-97D0-205DAB987247}" type="slidenum">
+              <a:rPr lang="en-US" smtClean="0"/>
+              <a:t>13</a:t>
+            </a:fld>
+            <a:endParaRPr lang="en-US"/>
+          </a:p>
+        </p:txBody>
+      </p:sp>
+    </p:spTree>
+    <p:extLst>
+      <p:ext uri="{BB962C8B-B14F-4D97-AF65-F5344CB8AC3E}">
+        <p14:creationId xmlns:p14="http://schemas.microsoft.com/office/powerpoint/2010/main" val="3150115669"/>
+      </p:ext>
+    </p:extLst>
+  </p:cSld>
+  <p:clrMapOvr>
+    <a:masterClrMapping/>
+  </p:clrMapOvr>
+</p:notes>
+</file>
+
+<file path=ppt/notesSlides/notesSlide9.xml><?xml version="1.0" encoding="utf-8"?>
+<p:notes xmlns:a="http://schemas.openxmlformats.org/drawingml/2006/main" xmlns:r="http://schemas.openxmlformats.org/officeDocument/2006/relationships" xmlns:p="http://schemas.openxmlformats.org/presentationml/2006/main">
+  <p:cSld>
+    <p:spTree>
+      <p:nvGrpSpPr>
+        <p:cNvPr id="1" name=""/>
+        <p:cNvGrpSpPr/>
+        <p:nvPr/>
+      </p:nvGrpSpPr>
+      <p:grpSpPr>
+        <a:xfrm>
+          <a:off x="0" y="0"/>
+          <a:ext cx="0" cy="0"/>
+          <a:chOff x="0" y="0"/>
+          <a:chExt cx="0" cy="0"/>
+        </a:xfrm>
+      </p:grpSpPr>
+      <p:sp>
+        <p:nvSpPr>
+          <p:cNvPr id="2" name="Slide Image Placeholder 1"/>
+          <p:cNvSpPr>
+            <a:spLocks noGrp="1" noRot="1" noChangeAspect="1"/>
+          </p:cNvSpPr>
+          <p:nvPr>
+            <p:ph type="sldImg"/>
+          </p:nvPr>
+        </p:nvSpPr>
+        <p:spPr/>
+      </p:sp>
+      <p:sp>
+        <p:nvSpPr>
+          <p:cNvPr id="3" name="Notes Placeholder 2"/>
+          <p:cNvSpPr>
+            <a:spLocks noGrp="1"/>
+          </p:cNvSpPr>
+          <p:nvPr>
+            <p:ph type="body" idx="1"/>
+          </p:nvPr>
+        </p:nvSpPr>
+        <p:spPr/>
+        <p:txBody>
+          <a:bodyPr/>
+          <a:lstStyle/>
+          <a:p>
+            <a:r>
+              <a:rPr lang="en-US" dirty="0"/>
+              <a:t>Pros:</a:t>
+            </a:r>
+          </a:p>
+          <a:p>
+            <a:pPr marL="171450" indent="-171450">
+              <a:buFontTx/>
+              <a:buChar char="-"/>
+            </a:pPr>
+            <a:r>
+              <a:rPr lang="en-US" dirty="0"/>
+              <a:t>Simple</a:t>
+            </a:r>
+          </a:p>
+          <a:p>
+            <a:pPr marL="171450" indent="-171450">
+              <a:buFontTx/>
+              <a:buChar char="-"/>
+            </a:pPr>
+            <a:r>
+              <a:rPr lang="en-US" dirty="0"/>
+              <a:t>Stateless</a:t>
+            </a:r>
+          </a:p>
+          <a:p>
+            <a:pPr marL="171450" indent="-171450">
+              <a:buFontTx/>
+              <a:buChar char="-"/>
+            </a:pPr>
+            <a:r>
+              <a:rPr lang="en-US" dirty="0"/>
+              <a:t>User-specific</a:t>
+            </a:r>
+          </a:p>
+          <a:p>
+            <a:pPr marL="0" indent="0">
+              <a:buFontTx/>
+              <a:buNone/>
+            </a:pPr>
+            <a:endParaRPr lang="en-US" dirty="0"/>
+          </a:p>
+          <a:p>
+            <a:pPr marL="0" indent="0">
+              <a:buFontTx/>
+              <a:buNone/>
+            </a:pPr>
+            <a:r>
+              <a:rPr lang="en-US" dirty="0"/>
+              <a:t>Cons;</a:t>
+            </a:r>
+          </a:p>
+          <a:p>
+            <a:pPr marL="171450" indent="-171450">
+              <a:buFontTx/>
+              <a:buChar char="-"/>
+            </a:pPr>
+            <a:r>
+              <a:rPr lang="en-US" dirty="0"/>
+              <a:t>Sending password repeatedly</a:t>
+            </a:r>
+          </a:p>
+          <a:p>
+            <a:pPr marL="171450" indent="-171450">
+              <a:buFontTx/>
+              <a:buChar char="-"/>
+            </a:pPr>
+            <a:r>
+              <a:rPr lang="en-US" dirty="0"/>
+              <a:t>Cannot auth 3rd parties</a:t>
+            </a:r>
+          </a:p>
+        </p:txBody>
+      </p:sp>
+      <p:sp>
+        <p:nvSpPr>
+          <p:cNvPr id="4" name="Slide Number Placeholder 3"/>
+          <p:cNvSpPr>
+            <a:spLocks noGrp="1"/>
+          </p:cNvSpPr>
+          <p:nvPr>
+            <p:ph type="sldNum" sz="quarter" idx="5"/>
+          </p:nvPr>
+        </p:nvSpPr>
+        <p:spPr/>
+        <p:txBody>
+          <a:bodyPr/>
+          <a:lstStyle/>
+          <a:p>
+            <a:fld id="{BE457D5F-ED05-449E-97D0-205DAB987247}" type="slidenum">
+              <a:rPr lang="en-US" smtClean="0"/>
+              <a:t>17</a:t>
+            </a:fld>
+            <a:endParaRPr lang="en-US"/>
+          </a:p>
+        </p:txBody>
+      </p:sp>
+    </p:spTree>
+    <p:extLst>
+      <p:ext uri="{BB962C8B-B14F-4D97-AF65-F5344CB8AC3E}">
+        <p14:creationId xmlns:p14="http://schemas.microsoft.com/office/powerpoint/2010/main" val="1265215026"/>
       </p:ext>
     </p:extLst>
   </p:cSld>
@@ -1198,7 +2046,7 @@
           <a:p>
             <a:fld id="{7A3E0868-4E26-4CDC-8A56-D70E2D8B12FE}" type="datetime3">
               <a:rPr lang="en-US" smtClean="0"/>
-              <a:t>22 June 2026</a:t>
+              <a:t>23 June 2026</a:t>
             </a:fld>
             <a:endParaRPr lang="en-US"/>
           </a:p>
@@ -3777,7 +4625,7 @@
           <a:p>
             <a:fld id="{A7B8021B-6105-4216-96FC-94348F216D0E}" type="datetime3">
               <a:rPr lang="en-US" smtClean="0"/>
-              <a:t>22 June 2026</a:t>
+              <a:t>23 June 2026</a:t>
             </a:fld>
             <a:endParaRPr lang="en-US"/>
           </a:p>
@@ -5498,7 +6346,7 @@
           <a:p>
             <a:fld id="{5D27CFAB-73E6-44A8-B862-B3306344E3F2}" type="datetime3">
               <a:rPr lang="en-US" smtClean="0"/>
-              <a:t>22 June 2026</a:t>
+              <a:t>23 June 2026</a:t>
             </a:fld>
             <a:endParaRPr lang="en-US"/>
           </a:p>
@@ -7312,7 +8160,7 @@
           <a:p>
             <a:fld id="{A9B2E784-A5F5-4301-881B-94AC8DBF9DED}" type="datetime3">
               <a:rPr lang="en-US" smtClean="0"/>
-              <a:t>22 June 2026</a:t>
+              <a:t>23 June 2026</a:t>
             </a:fld>
             <a:endParaRPr lang="en-US"/>
           </a:p>
@@ -7494,7 +8342,7 @@
           <a:p>
             <a:fld id="{18EAB3A5-9E92-4BB9-8F22-9632B4FBEDBA}" type="datetime3">
               <a:rPr lang="en-US" smtClean="0"/>
-              <a:t>22 June 2026</a:t>
+              <a:t>23 June 2026</a:t>
             </a:fld>
             <a:endParaRPr lang="en-US"/>
           </a:p>
@@ -7724,7 +8572,7 @@
           <a:p>
             <a:fld id="{40923810-5FB2-48C9-96CA-1DE2C4773142}" type="datetime3">
               <a:rPr lang="en-US" smtClean="0"/>
-              <a:t>22 June 2026</a:t>
+              <a:t>23 June 2026</a:t>
             </a:fld>
             <a:endParaRPr lang="en-US"/>
           </a:p>
@@ -8023,7 +8871,7 @@
           <a:p>
             <a:fld id="{E50EFF4B-86EB-42FB-93EA-7D8F9CB2466F}" type="datetime3">
               <a:rPr lang="en-US" smtClean="0"/>
-              <a:t>22 June 2026</a:t>
+              <a:t>23 June 2026</a:t>
             </a:fld>
             <a:endParaRPr lang="en-US"/>
           </a:p>
@@ -8653,7 +9501,7 @@
           <a:p>
             <a:fld id="{FB14FC24-E041-45E9-9A72-E5755A86890F}" type="datetime3">
               <a:rPr lang="en-US" smtClean="0"/>
-              <a:t>22 June 2026</a:t>
+              <a:t>23 June 2026</a:t>
             </a:fld>
             <a:endParaRPr lang="en-US"/>
           </a:p>
@@ -9540,7 +10388,7 @@
           <a:p>
             <a:fld id="{98A19125-94A7-4474-858C-FD9C4ABE9DDA}" type="datetime3">
               <a:rPr lang="en-US" smtClean="0"/>
-              <a:t>22 June 2026</a:t>
+              <a:t>23 June 2026</a:t>
             </a:fld>
             <a:endParaRPr lang="en-US"/>
           </a:p>
@@ -10679,7 +11527,7 @@
           <a:p>
             <a:fld id="{3BA0343D-C8D8-43CE-BB79-50DEA219DB07}" type="datetime3">
               <a:rPr lang="en-US" smtClean="0"/>
-              <a:t>22 June 2026</a:t>
+              <a:t>23 June 2026</a:t>
             </a:fld>
             <a:endParaRPr lang="en-US"/>
           </a:p>
@@ -10971,7 +11819,7 @@
           <a:p>
             <a:fld id="{453BD212-0B9F-4987-965F-AC83B2FC354F}" type="datetime3">
               <a:rPr lang="en-US" smtClean="0"/>
-              <a:t>22 June 2026</a:t>
+              <a:t>23 June 2026</a:t>
             </a:fld>
             <a:endParaRPr lang="en-US"/>
           </a:p>
@@ -11216,7 +12064,7 @@
           <a:p>
             <a:fld id="{6DDC931E-8CBE-4A3F-A034-9B6122C6DCDB}" type="datetime3">
               <a:rPr lang="en-US" smtClean="0"/>
-              <a:t>22 June 2026</a:t>
+              <a:t>23 June 2026</a:t>
             </a:fld>
             <a:endParaRPr lang="en-US"/>
           </a:p>
@@ -12994,7 +13842,7 @@
           <a:p>
             <a:fld id="{220AF9C2-5E8A-4308-AE6B-CA9B65007D0E}" type="datetime3">
               <a:rPr lang="en-US" smtClean="0"/>
-              <a:t>22 June 2026</a:t>
+              <a:t>23 June 2026</a:t>
             </a:fld>
             <a:endParaRPr lang="en-US"/>
           </a:p>
@@ -13310,7 +14158,7 @@
           <a:p>
             <a:fld id="{FF31E861-D2AF-431D-860B-DCF67C218052}" type="datetime3">
               <a:rPr lang="en-US" smtClean="0"/>
-              <a:t>22 June 2026</a:t>
+              <a:t>23 June 2026</a:t>
             </a:fld>
             <a:endParaRPr lang="en-US"/>
           </a:p>
@@ -13592,7 +14440,7 @@
           <a:p>
             <a:fld id="{D1DA25B2-AAF1-4C1F-AA38-12D5BFA7D4C8}" type="datetime3">
               <a:rPr lang="en-US" smtClean="0"/>
-              <a:t>22 June 2026</a:t>
+              <a:t>23 June 2026</a:t>
             </a:fld>
             <a:endParaRPr lang="en-US"/>
           </a:p>
@@ -13874,7 +14722,7 @@
           <a:p>
             <a:fld id="{A25C0F39-45D0-48E9-90B3-7FE8FCE561C8}" type="datetime3">
               <a:rPr lang="en-US" smtClean="0"/>
-              <a:t>22 June 2026</a:t>
+              <a:t>23 June 2026</a:t>
             </a:fld>
             <a:endParaRPr lang="en-US"/>
           </a:p>
@@ -14384,7 +15232,7 @@
           <a:p>
             <a:fld id="{9BAF1A3D-92FA-4F24-9781-74AFA516A230}" type="datetime3">
               <a:rPr lang="en-US" smtClean="0"/>
-              <a:t>22 June 2026</a:t>
+              <a:t>23 June 2026</a:t>
             </a:fld>
             <a:endParaRPr lang="en-US"/>
           </a:p>
@@ -14511,7 +15359,7 @@
           <a:p>
             <a:fld id="{5719C672-856D-4617-A693-8FE15749A9B7}" type="datetime3">
               <a:rPr lang="en-US" smtClean="0"/>
-              <a:t>22 June 2026</a:t>
+              <a:t>23 June 2026</a:t>
             </a:fld>
             <a:endParaRPr lang="en-US"/>
           </a:p>
@@ -14646,7 +15494,7 @@
           <a:p>
             <a:fld id="{5F6C764D-A39E-4C03-B161-E0BC66E8883B}" type="datetime3">
               <a:rPr lang="en-US" smtClean="0"/>
-              <a:t>22 June 2026</a:t>
+              <a:t>23 June 2026</a:t>
             </a:fld>
             <a:endParaRPr lang="en-US"/>
           </a:p>
@@ -14888,7 +15736,7 @@
           <a:p>
             <a:fld id="{6E3E33F9-20B7-4995-BE7D-165DBB597850}" type="datetime3">
               <a:rPr lang="en-US" smtClean="0"/>
-              <a:t>22 June 2026</a:t>
+              <a:t>23 June 2026</a:t>
             </a:fld>
             <a:endParaRPr lang="en-US"/>
           </a:p>
@@ -15001,7 +15849,7 @@
           <a:p>
             <a:fld id="{CD41C263-3501-4369-A962-62B6BF915CDE}" type="datetime3">
               <a:rPr lang="en-US" smtClean="0"/>
-              <a:t>22 June 2026</a:t>
+              <a:t>23 June 2026</a:t>
             </a:fld>
             <a:endParaRPr lang="en-US"/>
           </a:p>
@@ -15407,7 +16255,7 @@
           <a:p>
             <a:fld id="{B06F3EBE-B2E8-4992-9F00-9E4B44F057C0}" type="datetime3">
               <a:rPr lang="en-US" smtClean="0"/>
-              <a:t>22 June 2026</a:t>
+              <a:t>23 June 2026</a:t>
             </a:fld>
             <a:endParaRPr lang="en-US"/>
           </a:p>
@@ -15539,7 +16387,7 @@
           <a:p>
             <a:fld id="{D41656AB-D2E1-472E-8B95-0DF5C6E1D623}" type="datetime3">
               <a:rPr lang="en-US" smtClean="0"/>
-              <a:t>22 June 2026</a:t>
+              <a:t>23 June 2026</a:t>
             </a:fld>
             <a:endParaRPr lang="en-US"/>
           </a:p>
@@ -19731,7 +20579,7 @@
           <a:p>
             <a:fld id="{AD3160A9-B1E4-4AE8-B854-46ED2C2068C2}" type="datetimeFigureOut">
               <a:rPr lang="en-US" smtClean="0"/>
-              <a:t>22-Jun-26</a:t>
+              <a:t>23-Jun-26</a:t>
             </a:fld>
             <a:endParaRPr lang="en-US"/>
           </a:p>
@@ -20143,7 +20991,7 @@
           <a:p>
             <a:fld id="{AD3160A9-B1E4-4AE8-B854-46ED2C2068C2}" type="datetimeFigureOut">
               <a:rPr lang="en-US" smtClean="0"/>
-              <a:t>22-Jun-26</a:t>
+              <a:t>23-Jun-26</a:t>
             </a:fld>
             <a:endParaRPr lang="en-US"/>
           </a:p>
@@ -20418,7 +21266,7 @@
           <a:p>
             <a:fld id="{AD3160A9-B1E4-4AE8-B854-46ED2C2068C2}" type="datetimeFigureOut">
               <a:rPr lang="en-US" smtClean="0"/>
-              <a:t>22-Jun-26</a:t>
+              <a:t>23-Jun-26</a:t>
             </a:fld>
             <a:endParaRPr lang="en-US"/>
           </a:p>
@@ -20617,7 +21465,7 @@
           <a:p>
             <a:fld id="{AD622D1A-DF83-41A8-85FF-04D90BF831D3}" type="datetime3">
               <a:rPr lang="en-US" smtClean="0"/>
-              <a:t>22 June 2026</a:t>
+              <a:t>23 June 2026</a:t>
             </a:fld>
             <a:endParaRPr lang="en-US"/>
           </a:p>
@@ -20873,7 +21721,7 @@
           <a:p>
             <a:fld id="{334F72C3-CDF3-44A8-B602-1649B1728485}" type="datetime3">
               <a:rPr lang="en-US" smtClean="0"/>
-              <a:t>22 June 2026</a:t>
+              <a:t>23 June 2026</a:t>
             </a:fld>
             <a:endParaRPr lang="en-US"/>
           </a:p>
@@ -21189,7 +22037,7 @@
           <a:p>
             <a:fld id="{1E0132BA-B5E7-4FFD-AF6C-169169D47D4A}" type="datetime3">
               <a:rPr lang="en-US" smtClean="0"/>
-              <a:t>22 June 2026</a:t>
+              <a:t>23 June 2026</a:t>
             </a:fld>
             <a:endParaRPr lang="en-US"/>
           </a:p>
@@ -21682,7 +22530,7 @@
           <a:p>
             <a:fld id="{81A30091-1C2A-4151-8D3C-D1E47A72615F}" type="datetime3">
               <a:rPr lang="en-US" smtClean="0"/>
-              <a:t>22 June 2026</a:t>
+              <a:t>23 June 2026</a:t>
             </a:fld>
             <a:endParaRPr lang="en-US"/>
           </a:p>
@@ -22343,7 +23191,7 @@
           <a:p>
             <a:fld id="{35D703CE-07B4-4C05-A488-B4566700621F}" type="datetime3">
               <a:rPr lang="en-US" smtClean="0"/>
-              <a:t>22 June 2026</a:t>
+              <a:t>23 June 2026</a:t>
             </a:fld>
             <a:endParaRPr lang="en-US"/>
           </a:p>
@@ -23413,7 +24261,7 @@
           <a:p>
             <a:fld id="{694BD61C-20BA-43AF-A21F-1DAFB3200099}" type="datetime3">
               <a:rPr lang="en-US" smtClean="0"/>
-              <a:t>22 June 2026</a:t>
+              <a:t>23 June 2026</a:t>
             </a:fld>
             <a:endParaRPr lang="en-US"/>
           </a:p>
@@ -23900,7 +24748,7 @@
           <a:p>
             <a:fld id="{CABCB1B0-B6E5-4DD1-BB55-95C076D6C0C8}" type="datetime3">
               <a:rPr lang="en-US" smtClean="0"/>
-              <a:t>22 June 2026</a:t>
+              <a:t>23 June 2026</a:t>
             </a:fld>
             <a:endParaRPr lang="en-US"/>
           </a:p>
@@ -24922,7 +25770,7 @@
           <a:p>
             <a:fld id="{AD622D1A-DF83-41A8-85FF-04D90BF831D3}" type="datetime3">
               <a:rPr lang="en-US" smtClean="0"/>
-              <a:t>22 June 2026</a:t>
+              <a:t>23 June 2026</a:t>
             </a:fld>
             <a:endParaRPr lang="en-US"/>
           </a:p>
@@ -25067,7 +25915,7 @@
           <a:p>
             <a:fld id="{AD622D1A-DF83-41A8-85FF-04D90BF831D3}" type="datetime3">
               <a:rPr lang="en-US" smtClean="0"/>
-              <a:t>22 June 2026</a:t>
+              <a:t>23 June 2026</a:t>
             </a:fld>
             <a:endParaRPr lang="en-US"/>
           </a:p>
@@ -25209,7 +26057,7 @@
           <a:p>
             <a:fld id="{AD622D1A-DF83-41A8-85FF-04D90BF831D3}" type="datetime3">
               <a:rPr lang="en-US" smtClean="0"/>
-              <a:t>22 June 2026</a:t>
+              <a:t>23 June 2026</a:t>
             </a:fld>
             <a:endParaRPr lang="en-US"/>
           </a:p>
@@ -25259,6 +26107,969 @@
 </file>
 
 <file path=ppt/slides/slide13.xml><?xml version="1.0" encoding="utf-8"?>
+<p:sld xmlns:a="http://schemas.openxmlformats.org/drawingml/2006/main" xmlns:r="http://schemas.openxmlformats.org/officeDocument/2006/relationships" xmlns:p="http://schemas.openxmlformats.org/presentationml/2006/main">
+  <p:cSld>
+    <p:spTree>
+      <p:nvGrpSpPr>
+        <p:cNvPr id="1" name="">
+          <a:extLst>
+            <a:ext uri="{FF2B5EF4-FFF2-40B4-BE49-F238E27FC236}">
+              <a16:creationId xmlns:a16="http://schemas.microsoft.com/office/drawing/2014/main" id="{01560031-D8A1-AFDB-9E76-43EE5E2AEA80}"/>
+            </a:ext>
+          </a:extLst>
+        </p:cNvPr>
+        <p:cNvGrpSpPr/>
+        <p:nvPr/>
+      </p:nvGrpSpPr>
+      <p:grpSpPr>
+        <a:xfrm>
+          <a:off x="0" y="0"/>
+          <a:ext cx="0" cy="0"/>
+          <a:chOff x="0" y="0"/>
+          <a:chExt cx="0" cy="0"/>
+        </a:xfrm>
+      </p:grpSpPr>
+      <p:sp>
+        <p:nvSpPr>
+          <p:cNvPr id="2" name="Title 1">
+            <a:extLst>
+              <a:ext uri="{FF2B5EF4-FFF2-40B4-BE49-F238E27FC236}">
+                <a16:creationId xmlns:a16="http://schemas.microsoft.com/office/drawing/2014/main" id="{8A99A7FE-0FD6-1D55-7B5D-64F57EAE18A9}"/>
+              </a:ext>
+            </a:extLst>
+          </p:cNvPr>
+          <p:cNvSpPr>
+            <a:spLocks noGrp="1"/>
+          </p:cNvSpPr>
+          <p:nvPr>
+            <p:ph type="title"/>
+          </p:nvPr>
+        </p:nvSpPr>
+        <p:spPr>
+          <a:xfrm>
+            <a:off x="839788" y="365125"/>
+            <a:ext cx="10515600" cy="1325563"/>
+          </a:xfrm>
+        </p:spPr>
+        <p:txBody>
+          <a:bodyPr/>
+          <a:lstStyle/>
+          <a:p>
+            <a:r>
+              <a:rPr lang="en-US" dirty="0"/>
+              <a:t>API Terms</a:t>
+            </a:r>
+          </a:p>
+        </p:txBody>
+      </p:sp>
+      <p:sp>
+        <p:nvSpPr>
+          <p:cNvPr id="5" name="Text Placeholder 4">
+            <a:extLst>
+              <a:ext uri="{FF2B5EF4-FFF2-40B4-BE49-F238E27FC236}">
+                <a16:creationId xmlns:a16="http://schemas.microsoft.com/office/drawing/2014/main" id="{6F7A2A1E-639A-3D2A-DC66-A1A2DABA83D1}"/>
+              </a:ext>
+            </a:extLst>
+          </p:cNvPr>
+          <p:cNvSpPr>
+            <a:spLocks noGrp="1"/>
+          </p:cNvSpPr>
+          <p:nvPr>
+            <p:ph type="body" idx="1"/>
+          </p:nvPr>
+        </p:nvSpPr>
+        <p:spPr>
+          <a:xfrm>
+            <a:off x="839788" y="1681163"/>
+            <a:ext cx="5157787" cy="823912"/>
+          </a:xfrm>
+        </p:spPr>
+        <p:txBody>
+          <a:bodyPr/>
+          <a:lstStyle/>
+          <a:p>
+            <a:r>
+              <a:rPr lang="en-US" dirty="0"/>
+              <a:t>Request</a:t>
+            </a:r>
+          </a:p>
+        </p:txBody>
+      </p:sp>
+      <p:sp>
+        <p:nvSpPr>
+          <p:cNvPr id="6" name="Content Placeholder 5">
+            <a:extLst>
+              <a:ext uri="{FF2B5EF4-FFF2-40B4-BE49-F238E27FC236}">
+                <a16:creationId xmlns:a16="http://schemas.microsoft.com/office/drawing/2014/main" id="{0A6FD7DB-0070-9216-4EC2-A41C584EA58A}"/>
+              </a:ext>
+            </a:extLst>
+          </p:cNvPr>
+          <p:cNvSpPr>
+            <a:spLocks noGrp="1"/>
+          </p:cNvSpPr>
+          <p:nvPr>
+            <p:ph sz="half" idx="2"/>
+          </p:nvPr>
+        </p:nvSpPr>
+        <p:spPr>
+          <a:xfrm>
+            <a:off x="839788" y="2505075"/>
+            <a:ext cx="10512424" cy="3684588"/>
+          </a:xfrm>
+        </p:spPr>
+        <p:txBody>
+          <a:bodyPr>
+            <a:normAutofit/>
+          </a:bodyPr>
+          <a:lstStyle/>
+          <a:p>
+            <a:pPr marL="0" indent="0">
+              <a:buNone/>
+            </a:pPr>
+            <a:r>
+              <a:rPr lang="en-US" dirty="0">
+                <a:latin typeface="Courier New" panose="02070309020205020404" pitchFamily="49" charset="0"/>
+                <a:cs typeface="Courier New" panose="02070309020205020404" pitchFamily="49" charset="0"/>
+              </a:rPr>
+              <a:t>GET /users/{user}/</a:t>
+            </a:r>
+            <a:r>
+              <a:rPr lang="en-US" dirty="0" err="1">
+                <a:latin typeface="Courier New" panose="02070309020205020404" pitchFamily="49" charset="0"/>
+                <a:cs typeface="Courier New" panose="02070309020205020404" pitchFamily="49" charset="0"/>
+              </a:rPr>
+              <a:t>playlists?sort</a:t>
+            </a:r>
+            <a:r>
+              <a:rPr lang="en-US" dirty="0">
+                <a:latin typeface="Courier New" panose="02070309020205020404" pitchFamily="49" charset="0"/>
+                <a:cs typeface="Courier New" panose="02070309020205020404" pitchFamily="49" charset="0"/>
+              </a:rPr>
+              <a:t>={direction} HTTP/1.1\r\n</a:t>
+            </a:r>
+          </a:p>
+          <a:p>
+            <a:pPr marL="0" indent="0">
+              <a:buNone/>
+            </a:pPr>
+            <a:r>
+              <a:rPr lang="en-US" dirty="0">
+                <a:latin typeface="Courier New" panose="02070309020205020404" pitchFamily="49" charset="0"/>
+                <a:cs typeface="Courier New" panose="02070309020205020404" pitchFamily="49" charset="0"/>
+              </a:rPr>
+              <a:t>Host: example.com\r\n</a:t>
+            </a:r>
+          </a:p>
+          <a:p>
+            <a:pPr marL="0" indent="0">
+              <a:buNone/>
+            </a:pPr>
+            <a:r>
+              <a:rPr lang="en-US" dirty="0">
+                <a:latin typeface="Courier New" panose="02070309020205020404" pitchFamily="49" charset="0"/>
+                <a:cs typeface="Courier New" panose="02070309020205020404" pitchFamily="49" charset="0"/>
+              </a:rPr>
+              <a:t>Authentication: "Bearer 1234deadb33f"</a:t>
+            </a:r>
+          </a:p>
+          <a:p>
+            <a:pPr marL="0" indent="0">
+              <a:buNone/>
+            </a:pPr>
+            <a:r>
+              <a:rPr lang="en-US" dirty="0">
+                <a:latin typeface="Courier New" panose="02070309020205020404" pitchFamily="49" charset="0"/>
+                <a:cs typeface="Courier New" panose="02070309020205020404" pitchFamily="49" charset="0"/>
+              </a:rPr>
+              <a:t>Accept: */*\r\n</a:t>
+            </a:r>
+          </a:p>
+          <a:p>
+            <a:pPr marL="0" indent="0">
+              <a:buNone/>
+            </a:pPr>
+            <a:r>
+              <a:rPr lang="en-US" dirty="0">
+                <a:latin typeface="Courier New" panose="02070309020205020404" pitchFamily="49" charset="0"/>
+                <a:cs typeface="Courier New" panose="02070309020205020404" pitchFamily="49" charset="0"/>
+              </a:rPr>
+              <a:t>\r\n</a:t>
+            </a:r>
+          </a:p>
+          <a:p>
+            <a:pPr marL="0" indent="0">
+              <a:buNone/>
+            </a:pPr>
+            <a:r>
+              <a:rPr lang="en-US" dirty="0">
+                <a:latin typeface="Courier New" panose="02070309020205020404" pitchFamily="49" charset="0"/>
+                <a:cs typeface="Courier New" panose="02070309020205020404" pitchFamily="49" charset="0"/>
+              </a:rPr>
+              <a:t>{"genre": "rock"}\r\n</a:t>
+            </a:r>
+          </a:p>
+        </p:txBody>
+      </p:sp>
+      <p:sp>
+        <p:nvSpPr>
+          <p:cNvPr id="9" name="Rectangle 8">
+            <a:extLst>
+              <a:ext uri="{FF2B5EF4-FFF2-40B4-BE49-F238E27FC236}">
+                <a16:creationId xmlns:a16="http://schemas.microsoft.com/office/drawing/2014/main" id="{454316F9-3DCB-C2BB-D196-DF20A41BC0C8}"/>
+              </a:ext>
+            </a:extLst>
+          </p:cNvPr>
+          <p:cNvSpPr/>
+          <p:nvPr/>
+        </p:nvSpPr>
+        <p:spPr>
+          <a:xfrm>
+            <a:off x="1579853" y="2463419"/>
+            <a:ext cx="4169856" cy="451786"/>
+          </a:xfrm>
+          <a:prstGeom prst="rect">
+            <a:avLst/>
+          </a:prstGeom>
+          <a:noFill/>
+          <a:ln w="38100">
+            <a:solidFill>
+              <a:schemeClr val="accent2"/>
+            </a:solidFill>
+          </a:ln>
+        </p:spPr>
+        <p:style>
+          <a:lnRef idx="2">
+            <a:schemeClr val="accent1">
+              <a:shade val="15000"/>
+            </a:schemeClr>
+          </a:lnRef>
+          <a:fillRef idx="1">
+            <a:schemeClr val="accent1"/>
+          </a:fillRef>
+          <a:effectRef idx="0">
+            <a:schemeClr val="accent1"/>
+          </a:effectRef>
+          <a:fontRef idx="minor">
+            <a:schemeClr val="lt1"/>
+          </a:fontRef>
+        </p:style>
+        <p:txBody>
+          <a:bodyPr rtlCol="0" anchor="ctr"/>
+          <a:lstStyle/>
+          <a:p>
+            <a:pPr algn="ctr"/>
+            <a:endParaRPr lang="en-US"/>
+          </a:p>
+        </p:txBody>
+      </p:sp>
+      <p:sp>
+        <p:nvSpPr>
+          <p:cNvPr id="11" name="TextBox 10">
+            <a:extLst>
+              <a:ext uri="{FF2B5EF4-FFF2-40B4-BE49-F238E27FC236}">
+                <a16:creationId xmlns:a16="http://schemas.microsoft.com/office/drawing/2014/main" id="{0DDAB313-61F8-F1E1-0943-0A5CBD95E544}"/>
+              </a:ext>
+            </a:extLst>
+          </p:cNvPr>
+          <p:cNvSpPr txBox="1"/>
+          <p:nvPr/>
+        </p:nvSpPr>
+        <p:spPr>
+          <a:xfrm>
+            <a:off x="5997575" y="266440"/>
+            <a:ext cx="3734382" cy="1384995"/>
+          </a:xfrm>
+          <a:prstGeom prst="rect">
+            <a:avLst/>
+          </a:prstGeom>
+          <a:noFill/>
+        </p:spPr>
+        <p:txBody>
+          <a:bodyPr wrap="square" rtlCol="0">
+            <a:spAutoFit/>
+          </a:bodyPr>
+          <a:lstStyle/>
+          <a:p>
+            <a:r>
+              <a:rPr lang="en-US" sz="2800" dirty="0">
+                <a:solidFill>
+                  <a:schemeClr val="accent2"/>
+                </a:solidFill>
+              </a:rPr>
+              <a:t>Path</a:t>
+            </a:r>
+          </a:p>
+          <a:p>
+            <a:r>
+              <a:rPr lang="en-US" sz="2800" dirty="0">
+                <a:solidFill>
+                  <a:schemeClr val="accent4"/>
+                </a:solidFill>
+              </a:rPr>
+              <a:t>Query String</a:t>
+            </a:r>
+          </a:p>
+          <a:p>
+            <a:r>
+              <a:rPr lang="en-US" sz="2800" dirty="0">
+                <a:solidFill>
+                  <a:schemeClr val="accent6"/>
+                </a:solidFill>
+              </a:rPr>
+              <a:t>Body</a:t>
+            </a:r>
+          </a:p>
+        </p:txBody>
+      </p:sp>
+      <p:sp>
+        <p:nvSpPr>
+          <p:cNvPr id="12" name="Rectangle 11">
+            <a:extLst>
+              <a:ext uri="{FF2B5EF4-FFF2-40B4-BE49-F238E27FC236}">
+                <a16:creationId xmlns:a16="http://schemas.microsoft.com/office/drawing/2014/main" id="{16AA6916-796C-D3A1-77CC-0554582087C7}"/>
+              </a:ext>
+            </a:extLst>
+          </p:cNvPr>
+          <p:cNvSpPr/>
+          <p:nvPr/>
+        </p:nvSpPr>
+        <p:spPr>
+          <a:xfrm>
+            <a:off x="5946336" y="2463420"/>
+            <a:ext cx="2920426" cy="451786"/>
+          </a:xfrm>
+          <a:prstGeom prst="rect">
+            <a:avLst/>
+          </a:prstGeom>
+          <a:noFill/>
+          <a:ln w="38100">
+            <a:solidFill>
+              <a:schemeClr val="accent4"/>
+            </a:solidFill>
+          </a:ln>
+        </p:spPr>
+        <p:style>
+          <a:lnRef idx="2">
+            <a:schemeClr val="accent1">
+              <a:shade val="15000"/>
+            </a:schemeClr>
+          </a:lnRef>
+          <a:fillRef idx="1">
+            <a:schemeClr val="accent1"/>
+          </a:fillRef>
+          <a:effectRef idx="0">
+            <a:schemeClr val="accent1"/>
+          </a:effectRef>
+          <a:fontRef idx="minor">
+            <a:schemeClr val="lt1"/>
+          </a:fontRef>
+        </p:style>
+        <p:txBody>
+          <a:bodyPr rtlCol="0" anchor="ctr"/>
+          <a:lstStyle/>
+          <a:p>
+            <a:pPr algn="ctr"/>
+            <a:endParaRPr lang="en-US"/>
+          </a:p>
+        </p:txBody>
+      </p:sp>
+      <p:sp>
+        <p:nvSpPr>
+          <p:cNvPr id="14" name="Rectangle 13">
+            <a:extLst>
+              <a:ext uri="{FF2B5EF4-FFF2-40B4-BE49-F238E27FC236}">
+                <a16:creationId xmlns:a16="http://schemas.microsoft.com/office/drawing/2014/main" id="{146990E5-ED21-D729-4E7B-12F8F55A8DAB}"/>
+              </a:ext>
+            </a:extLst>
+          </p:cNvPr>
+          <p:cNvSpPr/>
+          <p:nvPr/>
+        </p:nvSpPr>
+        <p:spPr>
+          <a:xfrm>
+            <a:off x="799843" y="4812520"/>
+            <a:ext cx="3149790" cy="510667"/>
+          </a:xfrm>
+          <a:prstGeom prst="rect">
+            <a:avLst/>
+          </a:prstGeom>
+          <a:noFill/>
+          <a:ln w="38100">
+            <a:solidFill>
+              <a:schemeClr val="accent6"/>
+            </a:solidFill>
+          </a:ln>
+        </p:spPr>
+        <p:style>
+          <a:lnRef idx="2">
+            <a:schemeClr val="accent1">
+              <a:shade val="15000"/>
+            </a:schemeClr>
+          </a:lnRef>
+          <a:fillRef idx="1">
+            <a:schemeClr val="accent1"/>
+          </a:fillRef>
+          <a:effectRef idx="0">
+            <a:schemeClr val="accent1"/>
+          </a:effectRef>
+          <a:fontRef idx="minor">
+            <a:schemeClr val="lt1"/>
+          </a:fontRef>
+        </p:style>
+        <p:txBody>
+          <a:bodyPr rtlCol="0" anchor="ctr"/>
+          <a:lstStyle/>
+          <a:p>
+            <a:pPr algn="ctr"/>
+            <a:endParaRPr lang="en-US"/>
+          </a:p>
+        </p:txBody>
+      </p:sp>
+    </p:spTree>
+    <p:extLst>
+      <p:ext uri="{BB962C8B-B14F-4D97-AF65-F5344CB8AC3E}">
+        <p14:creationId xmlns:p14="http://schemas.microsoft.com/office/powerpoint/2010/main" val="2914651355"/>
+      </p:ext>
+    </p:extLst>
+  </p:cSld>
+  <p:clrMapOvr>
+    <a:masterClrMapping/>
+  </p:clrMapOvr>
+  <p:timing>
+    <p:tnLst>
+      <p:par>
+        <p:cTn id="1" dur="indefinite" restart="never" nodeType="tmRoot">
+          <p:childTnLst>
+            <p:seq concurrent="1" nextAc="seek">
+              <p:cTn id="2" dur="indefinite" nodeType="mainSeq">
+                <p:childTnLst>
+                  <p:par>
+                    <p:cTn id="3" fill="hold">
+                      <p:stCondLst>
+                        <p:cond delay="indefinite"/>
+                      </p:stCondLst>
+                      <p:childTnLst>
+                        <p:par>
+                          <p:cTn id="4" fill="hold">
+                            <p:stCondLst>
+                              <p:cond delay="0"/>
+                            </p:stCondLst>
+                            <p:childTnLst>
+                              <p:par>
+                                <p:cTn id="5" presetID="1" presetClass="entr" presetSubtype="0" fill="hold" grpId="0" nodeType="clickEffect">
+                                  <p:stCondLst>
+                                    <p:cond delay="0"/>
+                                  </p:stCondLst>
+                                  <p:childTnLst>
+                                    <p:set>
+                                      <p:cBhvr>
+                                        <p:cTn id="6" dur="1" fill="hold">
+                                          <p:stCondLst>
+                                            <p:cond delay="0"/>
+                                          </p:stCondLst>
+                                        </p:cTn>
+                                        <p:tgtEl>
+                                          <p:spTgt spid="11"/>
+                                        </p:tgtEl>
+                                        <p:attrNameLst>
+                                          <p:attrName>style.visibility</p:attrName>
+                                        </p:attrNameLst>
+                                      </p:cBhvr>
+                                      <p:to>
+                                        <p:strVal val="visible"/>
+                                      </p:to>
+                                    </p:set>
+                                  </p:childTnLst>
+                                </p:cTn>
+                              </p:par>
+                              <p:par>
+                                <p:cTn id="7" presetID="1" presetClass="entr" presetSubtype="0" fill="hold" grpId="0" nodeType="withEffect">
+                                  <p:stCondLst>
+                                    <p:cond delay="0"/>
+                                  </p:stCondLst>
+                                  <p:childTnLst>
+                                    <p:set>
+                                      <p:cBhvr>
+                                        <p:cTn id="8" dur="1" fill="hold">
+                                          <p:stCondLst>
+                                            <p:cond delay="0"/>
+                                          </p:stCondLst>
+                                        </p:cTn>
+                                        <p:tgtEl>
+                                          <p:spTgt spid="9"/>
+                                        </p:tgtEl>
+                                        <p:attrNameLst>
+                                          <p:attrName>style.visibility</p:attrName>
+                                        </p:attrNameLst>
+                                      </p:cBhvr>
+                                      <p:to>
+                                        <p:strVal val="visible"/>
+                                      </p:to>
+                                    </p:set>
+                                  </p:childTnLst>
+                                </p:cTn>
+                              </p:par>
+                              <p:par>
+                                <p:cTn id="9" presetID="1" presetClass="entr" presetSubtype="0" fill="hold" grpId="0" nodeType="withEffect">
+                                  <p:stCondLst>
+                                    <p:cond delay="0"/>
+                                  </p:stCondLst>
+                                  <p:childTnLst>
+                                    <p:set>
+                                      <p:cBhvr>
+                                        <p:cTn id="10" dur="1" fill="hold">
+                                          <p:stCondLst>
+                                            <p:cond delay="0"/>
+                                          </p:stCondLst>
+                                        </p:cTn>
+                                        <p:tgtEl>
+                                          <p:spTgt spid="12"/>
+                                        </p:tgtEl>
+                                        <p:attrNameLst>
+                                          <p:attrName>style.visibility</p:attrName>
+                                        </p:attrNameLst>
+                                      </p:cBhvr>
+                                      <p:to>
+                                        <p:strVal val="visible"/>
+                                      </p:to>
+                                    </p:set>
+                                  </p:childTnLst>
+                                </p:cTn>
+                              </p:par>
+                              <p:par>
+                                <p:cTn id="11" presetID="1" presetClass="entr" presetSubtype="0" fill="hold" grpId="0" nodeType="withEffect">
+                                  <p:stCondLst>
+                                    <p:cond delay="0"/>
+                                  </p:stCondLst>
+                                  <p:childTnLst>
+                                    <p:set>
+                                      <p:cBhvr>
+                                        <p:cTn id="12" dur="1" fill="hold">
+                                          <p:stCondLst>
+                                            <p:cond delay="0"/>
+                                          </p:stCondLst>
+                                        </p:cTn>
+                                        <p:tgtEl>
+                                          <p:spTgt spid="14"/>
+                                        </p:tgtEl>
+                                        <p:attrNameLst>
+                                          <p:attrName>style.visibility</p:attrName>
+                                        </p:attrNameLst>
+                                      </p:cBhvr>
+                                      <p:to>
+                                        <p:strVal val="visible"/>
+                                      </p:to>
+                                    </p:set>
+                                  </p:childTnLst>
+                                </p:cTn>
+                              </p:par>
+                            </p:childTnLst>
+                          </p:cTn>
+                        </p:par>
+                      </p:childTnLst>
+                    </p:cTn>
+                  </p:par>
+                </p:childTnLst>
+              </p:cTn>
+              <p:prevCondLst>
+                <p:cond evt="onPrev" delay="0">
+                  <p:tgtEl>
+                    <p:sldTgt/>
+                  </p:tgtEl>
+                </p:cond>
+              </p:prevCondLst>
+              <p:nextCondLst>
+                <p:cond evt="onNext" delay="0">
+                  <p:tgtEl>
+                    <p:sldTgt/>
+                  </p:tgtEl>
+                </p:cond>
+              </p:nextCondLst>
+            </p:seq>
+          </p:childTnLst>
+        </p:cTn>
+      </p:par>
+    </p:tnLst>
+    <p:bldLst>
+      <p:bldP spid="9" grpId="0" animBg="1"/>
+      <p:bldP spid="11" grpId="0"/>
+      <p:bldP spid="12" grpId="0" animBg="1"/>
+      <p:bldP spid="14" grpId="0" animBg="1"/>
+    </p:bldLst>
+  </p:timing>
+</p:sld>
+</file>
+
+<file path=ppt/slides/slide14.xml><?xml version="1.0" encoding="utf-8"?>
+<p:sld xmlns:a="http://schemas.openxmlformats.org/drawingml/2006/main" xmlns:r="http://schemas.openxmlformats.org/officeDocument/2006/relationships" xmlns:p="http://schemas.openxmlformats.org/presentationml/2006/main">
+  <p:cSld>
+    <p:spTree>
+      <p:nvGrpSpPr>
+        <p:cNvPr id="1" name="">
+          <a:extLst>
+            <a:ext uri="{FF2B5EF4-FFF2-40B4-BE49-F238E27FC236}">
+              <a16:creationId xmlns:a16="http://schemas.microsoft.com/office/drawing/2014/main" id="{96186578-1CC0-B5DF-151B-592305F58BD5}"/>
+            </a:ext>
+          </a:extLst>
+        </p:cNvPr>
+        <p:cNvGrpSpPr/>
+        <p:nvPr/>
+      </p:nvGrpSpPr>
+      <p:grpSpPr>
+        <a:xfrm>
+          <a:off x="0" y="0"/>
+          <a:ext cx="0" cy="0"/>
+          <a:chOff x="0" y="0"/>
+          <a:chExt cx="0" cy="0"/>
+        </a:xfrm>
+      </p:grpSpPr>
+      <p:sp>
+        <p:nvSpPr>
+          <p:cNvPr id="2" name="Title 1">
+            <a:extLst>
+              <a:ext uri="{FF2B5EF4-FFF2-40B4-BE49-F238E27FC236}">
+                <a16:creationId xmlns:a16="http://schemas.microsoft.com/office/drawing/2014/main" id="{75E60273-FE3B-1138-04F9-B3122CECEC99}"/>
+              </a:ext>
+            </a:extLst>
+          </p:cNvPr>
+          <p:cNvSpPr>
+            <a:spLocks noGrp="1"/>
+          </p:cNvSpPr>
+          <p:nvPr>
+            <p:ph type="title"/>
+          </p:nvPr>
+        </p:nvSpPr>
+        <p:spPr/>
+        <p:txBody>
+          <a:bodyPr/>
+          <a:lstStyle/>
+          <a:p>
+            <a:r>
+              <a:rPr lang="en-US" dirty="0"/>
+              <a:t>Reading API Docs</a:t>
+            </a:r>
+          </a:p>
+        </p:txBody>
+      </p:sp>
+      <p:sp>
+        <p:nvSpPr>
+          <p:cNvPr id="3" name="Content Placeholder 2">
+            <a:extLst>
+              <a:ext uri="{FF2B5EF4-FFF2-40B4-BE49-F238E27FC236}">
+                <a16:creationId xmlns:a16="http://schemas.microsoft.com/office/drawing/2014/main" id="{201CFD5C-421C-65DD-83BA-CA41D7ED8DA8}"/>
+              </a:ext>
+            </a:extLst>
+          </p:cNvPr>
+          <p:cNvSpPr>
+            <a:spLocks noGrp="1"/>
+          </p:cNvSpPr>
+          <p:nvPr>
+            <p:ph idx="1"/>
+          </p:nvPr>
+        </p:nvSpPr>
+        <p:spPr/>
+        <p:txBody>
+          <a:bodyPr/>
+          <a:lstStyle/>
+          <a:p>
+            <a:r>
+              <a:rPr lang="en-US" dirty="0"/>
+              <a:t>PayPal example</a:t>
+            </a:r>
+          </a:p>
+        </p:txBody>
+      </p:sp>
+      <p:sp>
+        <p:nvSpPr>
+          <p:cNvPr id="4" name="Date Placeholder 3">
+            <a:extLst>
+              <a:ext uri="{FF2B5EF4-FFF2-40B4-BE49-F238E27FC236}">
+                <a16:creationId xmlns:a16="http://schemas.microsoft.com/office/drawing/2014/main" id="{F28F99AA-E72F-EC8E-8676-7CDBDE97CBD8}"/>
+              </a:ext>
+            </a:extLst>
+          </p:cNvPr>
+          <p:cNvSpPr>
+            <a:spLocks noGrp="1"/>
+          </p:cNvSpPr>
+          <p:nvPr>
+            <p:ph type="dt" sz="half" idx="10"/>
+          </p:nvPr>
+        </p:nvSpPr>
+        <p:spPr/>
+        <p:txBody>
+          <a:bodyPr/>
+          <a:lstStyle/>
+          <a:p>
+            <a:fld id="{AD622D1A-DF83-41A8-85FF-04D90BF831D3}" type="datetime3">
+              <a:rPr lang="en-US" smtClean="0"/>
+              <a:t>23 June 2026</a:t>
+            </a:fld>
+            <a:endParaRPr lang="en-US"/>
+          </a:p>
+        </p:txBody>
+      </p:sp>
+      <p:sp>
+        <p:nvSpPr>
+          <p:cNvPr id="5" name="Slide Number Placeholder 4">
+            <a:extLst>
+              <a:ext uri="{FF2B5EF4-FFF2-40B4-BE49-F238E27FC236}">
+                <a16:creationId xmlns:a16="http://schemas.microsoft.com/office/drawing/2014/main" id="{A9E51041-96C6-2AEF-A8DF-D0613E8714B7}"/>
+              </a:ext>
+            </a:extLst>
+          </p:cNvPr>
+          <p:cNvSpPr>
+            <a:spLocks noGrp="1"/>
+          </p:cNvSpPr>
+          <p:nvPr>
+            <p:ph type="sldNum" sz="quarter" idx="11"/>
+          </p:nvPr>
+        </p:nvSpPr>
+        <p:spPr/>
+        <p:txBody>
+          <a:bodyPr/>
+          <a:lstStyle/>
+          <a:p>
+            <a:fld id="{64E5BE4B-2FBF-4174-9E62-85FAD1CB43A6}" type="slidenum">
+              <a:rPr lang="en-US" smtClean="0"/>
+              <a:pPr/>
+              <a:t>14</a:t>
+            </a:fld>
+            <a:endParaRPr lang="en-US"/>
+          </a:p>
+        </p:txBody>
+      </p:sp>
+    </p:spTree>
+    <p:extLst>
+      <p:ext uri="{BB962C8B-B14F-4D97-AF65-F5344CB8AC3E}">
+        <p14:creationId xmlns:p14="http://schemas.microsoft.com/office/powerpoint/2010/main" val="2045984567"/>
+      </p:ext>
+    </p:extLst>
+  </p:cSld>
+  <p:clrMapOvr>
+    <a:masterClrMapping/>
+  </p:clrMapOvr>
+</p:sld>
+</file>
+
+<file path=ppt/slides/slide15.xml><?xml version="1.0" encoding="utf-8"?>
+<p:sld xmlns:a="http://schemas.openxmlformats.org/drawingml/2006/main" xmlns:r="http://schemas.openxmlformats.org/officeDocument/2006/relationships" xmlns:p="http://schemas.openxmlformats.org/presentationml/2006/main">
+  <p:cSld>
+    <p:spTree>
+      <p:nvGrpSpPr>
+        <p:cNvPr id="1" name=""/>
+        <p:cNvGrpSpPr/>
+        <p:nvPr/>
+      </p:nvGrpSpPr>
+      <p:grpSpPr>
+        <a:xfrm>
+          <a:off x="0" y="0"/>
+          <a:ext cx="0" cy="0"/>
+          <a:chOff x="0" y="0"/>
+          <a:chExt cx="0" cy="0"/>
+        </a:xfrm>
+      </p:grpSpPr>
+      <p:sp>
+        <p:nvSpPr>
+          <p:cNvPr id="2" name="Title 1">
+            <a:extLst>
+              <a:ext uri="{FF2B5EF4-FFF2-40B4-BE49-F238E27FC236}">
+                <a16:creationId xmlns:a16="http://schemas.microsoft.com/office/drawing/2014/main" id="{4FE4909E-0777-2269-30A3-E18FCC6D72AD}"/>
+              </a:ext>
+            </a:extLst>
+          </p:cNvPr>
+          <p:cNvSpPr>
+            <a:spLocks noGrp="1"/>
+          </p:cNvSpPr>
+          <p:nvPr>
+            <p:ph type="title"/>
+          </p:nvPr>
+        </p:nvSpPr>
+        <p:spPr/>
+        <p:txBody>
+          <a:bodyPr/>
+          <a:lstStyle/>
+          <a:p>
+            <a:r>
+              <a:rPr lang="en-US" dirty="0"/>
+              <a:t>Reading API Docs</a:t>
+            </a:r>
+          </a:p>
+        </p:txBody>
+      </p:sp>
+      <p:sp>
+        <p:nvSpPr>
+          <p:cNvPr id="3" name="Content Placeholder 2">
+            <a:extLst>
+              <a:ext uri="{FF2B5EF4-FFF2-40B4-BE49-F238E27FC236}">
+                <a16:creationId xmlns:a16="http://schemas.microsoft.com/office/drawing/2014/main" id="{0621767E-A648-7020-1001-2A53FE820F74}"/>
+              </a:ext>
+            </a:extLst>
+          </p:cNvPr>
+          <p:cNvSpPr>
+            <a:spLocks noGrp="1"/>
+          </p:cNvSpPr>
+          <p:nvPr>
+            <p:ph idx="1"/>
+          </p:nvPr>
+        </p:nvSpPr>
+        <p:spPr/>
+        <p:txBody>
+          <a:bodyPr/>
+          <a:lstStyle/>
+          <a:p>
+            <a:r>
+              <a:rPr lang="en-US" dirty="0"/>
+              <a:t>In groups:</a:t>
+            </a:r>
+          </a:p>
+          <a:p>
+            <a:pPr lvl="1"/>
+            <a:r>
+              <a:rPr lang="en-US" dirty="0"/>
+              <a:t>Endpoint, e.g. </a:t>
+            </a:r>
+            <a:r>
+              <a:rPr lang="en-US" dirty="0">
+                <a:hlinkClick r:id="rId2"/>
+              </a:rPr>
+              <a:t>https://api.github.com/repos/{owner}/{repo}/commits</a:t>
+            </a:r>
+            <a:endParaRPr lang="en-US" dirty="0"/>
+          </a:p>
+          <a:p>
+            <a:pPr lvl="1"/>
+            <a:r>
+              <a:rPr lang="en-US" dirty="0"/>
+              <a:t>Required parameters (path, body, or query string?)</a:t>
+            </a:r>
+          </a:p>
+          <a:p>
+            <a:pPr lvl="1"/>
+            <a:r>
+              <a:rPr lang="en-US" dirty="0"/>
+              <a:t>Optional parameters (path, body, or query string?)</a:t>
+            </a:r>
+          </a:p>
+          <a:p>
+            <a:pPr lvl="1"/>
+            <a:r>
+              <a:rPr lang="en-US" dirty="0"/>
+              <a:t>How do they handle multiple responses (e.g. 1000 commits)?</a:t>
+            </a:r>
+          </a:p>
+          <a:p>
+            <a:r>
+              <a:rPr lang="en-US" dirty="0"/>
+              <a:t>Groups:</a:t>
+            </a:r>
+          </a:p>
+          <a:p>
+            <a:pPr lvl="1"/>
+            <a:r>
+              <a:rPr lang="en-US" dirty="0"/>
+              <a:t>Compare two commits in GitHub</a:t>
+            </a:r>
+          </a:p>
+          <a:p>
+            <a:pPr lvl="1"/>
+            <a:r>
+              <a:rPr lang="en-US" dirty="0"/>
+              <a:t>Plan a route using Google Maps</a:t>
+            </a:r>
+          </a:p>
+          <a:p>
+            <a:pPr lvl="1"/>
+            <a:r>
+              <a:rPr lang="en-US" dirty="0"/>
+              <a:t>See my abandoned carts in Shopify</a:t>
+            </a:r>
+          </a:p>
+          <a:p>
+            <a:pPr lvl="1"/>
+            <a:r>
+              <a:rPr lang="en-US" dirty="0"/>
+              <a:t>Create a new Spotify playlist</a:t>
+            </a:r>
+          </a:p>
+          <a:p>
+            <a:pPr lvl="1"/>
+            <a:endParaRPr lang="en-US" dirty="0"/>
+          </a:p>
+        </p:txBody>
+      </p:sp>
+      <p:sp>
+        <p:nvSpPr>
+          <p:cNvPr id="4" name="Date Placeholder 3">
+            <a:extLst>
+              <a:ext uri="{FF2B5EF4-FFF2-40B4-BE49-F238E27FC236}">
+                <a16:creationId xmlns:a16="http://schemas.microsoft.com/office/drawing/2014/main" id="{1F009396-804B-8C57-3DD3-80E2F254CC02}"/>
+              </a:ext>
+            </a:extLst>
+          </p:cNvPr>
+          <p:cNvSpPr>
+            <a:spLocks noGrp="1"/>
+          </p:cNvSpPr>
+          <p:nvPr>
+            <p:ph type="dt" sz="half" idx="10"/>
+          </p:nvPr>
+        </p:nvSpPr>
+        <p:spPr/>
+        <p:txBody>
+          <a:bodyPr/>
+          <a:lstStyle/>
+          <a:p>
+            <a:fld id="{AD622D1A-DF83-41A8-85FF-04D90BF831D3}" type="datetime3">
+              <a:rPr lang="en-US" smtClean="0"/>
+              <a:t>23 June 2026</a:t>
+            </a:fld>
+            <a:endParaRPr lang="en-US"/>
+          </a:p>
+        </p:txBody>
+      </p:sp>
+      <p:sp>
+        <p:nvSpPr>
+          <p:cNvPr id="5" name="Slide Number Placeholder 4">
+            <a:extLst>
+              <a:ext uri="{FF2B5EF4-FFF2-40B4-BE49-F238E27FC236}">
+                <a16:creationId xmlns:a16="http://schemas.microsoft.com/office/drawing/2014/main" id="{F35BF542-8CEA-C17D-1DC5-D67DFFAD4C67}"/>
+              </a:ext>
+            </a:extLst>
+          </p:cNvPr>
+          <p:cNvSpPr>
+            <a:spLocks noGrp="1"/>
+          </p:cNvSpPr>
+          <p:nvPr>
+            <p:ph type="sldNum" sz="quarter" idx="11"/>
+          </p:nvPr>
+        </p:nvSpPr>
+        <p:spPr/>
+        <p:txBody>
+          <a:bodyPr/>
+          <a:lstStyle/>
+          <a:p>
+            <a:fld id="{64E5BE4B-2FBF-4174-9E62-85FAD1CB43A6}" type="slidenum">
+              <a:rPr lang="en-US" smtClean="0"/>
+              <a:pPr/>
+              <a:t>15</a:t>
+            </a:fld>
+            <a:endParaRPr lang="en-US"/>
+          </a:p>
+        </p:txBody>
+      </p:sp>
+    </p:spTree>
+    <p:extLst>
+      <p:ext uri="{BB962C8B-B14F-4D97-AF65-F5344CB8AC3E}">
+        <p14:creationId xmlns:p14="http://schemas.microsoft.com/office/powerpoint/2010/main" val="246403975"/>
+      </p:ext>
+    </p:extLst>
+  </p:cSld>
+  <p:clrMapOvr>
+    <a:masterClrMapping/>
+  </p:clrMapOvr>
+</p:sld>
+</file>
+
+<file path=ppt/slides/slide16.xml><?xml version="1.0" encoding="utf-8"?>
 <p:sld xmlns:a="http://schemas.openxmlformats.org/drawingml/2006/main" xmlns:r="http://schemas.openxmlformats.org/officeDocument/2006/relationships" xmlns:p="http://schemas.openxmlformats.org/presentationml/2006/main">
   <p:cSld>
     <p:spTree>
@@ -25340,7 +27151,16 @@
           <a:bodyPr/>
           <a:lstStyle/>
           <a:p>
-            <a:endParaRPr lang="en-US" dirty="0"/>
+            <a:r>
+              <a:rPr lang="en-US" dirty="0"/>
+              <a:t>Authorization vs Authentication?</a:t>
+            </a:r>
+          </a:p>
+          <a:p>
+            <a:r>
+              <a:rPr lang="en-US" dirty="0"/>
+              <a:t>How does a stateless protocol handle authentication?</a:t>
+            </a:r>
           </a:p>
         </p:txBody>
       </p:sp>
@@ -25357,7 +27177,7 @@
 </p:sld>
 </file>
 
-<file path=ppt/slides/slide14.xml><?xml version="1.0" encoding="utf-8"?>
+<file path=ppt/slides/slide17.xml><?xml version="1.0" encoding="utf-8"?>
 <p:sld xmlns:a="http://schemas.openxmlformats.org/drawingml/2006/main" xmlns:r="http://schemas.openxmlformats.org/officeDocument/2006/relationships" xmlns:p="http://schemas.openxmlformats.org/presentationml/2006/main">
   <p:cSld>
     <p:spTree>
@@ -25376,10 +27196,10 @@
       </p:grpSpPr>
       <p:sp>
         <p:nvSpPr>
-          <p:cNvPr id="5" name="Title 4">
-            <a:extLst>
-              <a:ext uri="{FF2B5EF4-FFF2-40B4-BE49-F238E27FC236}">
-                <a16:creationId xmlns:a16="http://schemas.microsoft.com/office/drawing/2014/main" id="{694CC769-791B-48CC-8DD8-3E436EE0B1A3}"/>
+          <p:cNvPr id="2" name="Title 1">
+            <a:extLst>
+              <a:ext uri="{FF2B5EF4-FFF2-40B4-BE49-F238E27FC236}">
+                <a16:creationId xmlns:a16="http://schemas.microsoft.com/office/drawing/2014/main" id="{706591C8-6A58-E40E-FED1-94B89E967D7A}"/>
               </a:ext>
             </a:extLst>
           </p:cNvPr>
@@ -25390,52 +27210,752 @@
             <p:ph type="title"/>
           </p:nvPr>
         </p:nvSpPr>
+        <p:spPr/>
+        <p:txBody>
+          <a:bodyPr/>
+          <a:lstStyle/>
+          <a:p>
+            <a:r>
+              <a:rPr lang="en-US" dirty="0"/>
+              <a:t>Basic Authentication</a:t>
+            </a:r>
+          </a:p>
+        </p:txBody>
+      </p:sp>
+      <p:sp>
+        <p:nvSpPr>
+          <p:cNvPr id="4" name="Date Placeholder 3">
+            <a:extLst>
+              <a:ext uri="{FF2B5EF4-FFF2-40B4-BE49-F238E27FC236}">
+                <a16:creationId xmlns:a16="http://schemas.microsoft.com/office/drawing/2014/main" id="{1AF0D519-2DAF-50D0-D67D-A7339A2417E3}"/>
+              </a:ext>
+            </a:extLst>
+          </p:cNvPr>
+          <p:cNvSpPr>
+            <a:spLocks noGrp="1"/>
+          </p:cNvSpPr>
+          <p:nvPr>
+            <p:ph type="dt" sz="half" idx="10"/>
+          </p:nvPr>
+        </p:nvSpPr>
+        <p:spPr/>
+        <p:txBody>
+          <a:bodyPr/>
+          <a:lstStyle/>
+          <a:p>
+            <a:fld id="{AD622D1A-DF83-41A8-85FF-04D90BF831D3}" type="datetime3">
+              <a:rPr lang="en-US" smtClean="0"/>
+              <a:t>23 June 2026</a:t>
+            </a:fld>
+            <a:endParaRPr lang="en-US"/>
+          </a:p>
+        </p:txBody>
+      </p:sp>
+      <p:sp>
+        <p:nvSpPr>
+          <p:cNvPr id="5" name="Slide Number Placeholder 4">
+            <a:extLst>
+              <a:ext uri="{FF2B5EF4-FFF2-40B4-BE49-F238E27FC236}">
+                <a16:creationId xmlns:a16="http://schemas.microsoft.com/office/drawing/2014/main" id="{51E82177-F9BA-551A-7FD4-EE526677556D}"/>
+              </a:ext>
+            </a:extLst>
+          </p:cNvPr>
+          <p:cNvSpPr>
+            <a:spLocks noGrp="1"/>
+          </p:cNvSpPr>
+          <p:nvPr>
+            <p:ph type="sldNum" sz="quarter" idx="11"/>
+          </p:nvPr>
+        </p:nvSpPr>
+        <p:spPr/>
+        <p:txBody>
+          <a:bodyPr/>
+          <a:lstStyle/>
+          <a:p>
+            <a:fld id="{64E5BE4B-2FBF-4174-9E62-85FAD1CB43A6}" type="slidenum">
+              <a:rPr lang="en-US" smtClean="0"/>
+              <a:pPr/>
+              <a:t>17</a:t>
+            </a:fld>
+            <a:endParaRPr lang="en-US"/>
+          </a:p>
+        </p:txBody>
+      </p:sp>
+      <p:pic>
+        <p:nvPicPr>
+          <p:cNvPr id="9" name="Content Placeholder 8" descr="Basic Authentication in ASP.NET Web API | Microsoft Learn">
+            <a:extLst>
+              <a:ext uri="{FF2B5EF4-FFF2-40B4-BE49-F238E27FC236}">
+                <a16:creationId xmlns:a16="http://schemas.microsoft.com/office/drawing/2014/main" id="{60AF7BFE-693A-B09F-DAAF-A592C0D5C41E}"/>
+              </a:ext>
+            </a:extLst>
+          </p:cNvPr>
+          <p:cNvPicPr>
+            <a:picLocks noGrp="1" noChangeAspect="1"/>
+          </p:cNvPicPr>
+          <p:nvPr>
+            <p:ph idx="1"/>
+          </p:nvPr>
+        </p:nvPicPr>
+        <p:blipFill>
+          <a:blip r:embed="rId3"/>
+          <a:stretch>
+            <a:fillRect/>
+          </a:stretch>
+        </p:blipFill>
         <p:spPr>
           <a:xfrm>
-            <a:off x="831850" y="1709738"/>
-            <a:ext cx="10515600" cy="2852737"/>
+            <a:off x="2491874" y="1267797"/>
+            <a:ext cx="7208252" cy="3117493"/>
           </a:xfrm>
+          <a:prstGeom prst="rect">
+            <a:avLst/>
+          </a:prstGeom>
         </p:spPr>
-        <p:txBody>
-          <a:bodyPr/>
+      </p:pic>
+      <p:sp>
+        <p:nvSpPr>
+          <p:cNvPr id="10" name="TextBox 9">
+            <a:extLst>
+              <a:ext uri="{FF2B5EF4-FFF2-40B4-BE49-F238E27FC236}">
+                <a16:creationId xmlns:a16="http://schemas.microsoft.com/office/drawing/2014/main" id="{276CF770-DEF0-59F3-36A0-2AA911530487}"/>
+              </a:ext>
+            </a:extLst>
+          </p:cNvPr>
+          <p:cNvSpPr txBox="1"/>
+          <p:nvPr/>
+        </p:nvSpPr>
+        <p:spPr>
+          <a:xfrm>
+            <a:off x="1666028" y="5203941"/>
+            <a:ext cx="2341056" cy="339908"/>
+          </a:xfrm>
+          <a:prstGeom prst="rect">
+            <a:avLst/>
+          </a:prstGeom>
+          <a:noFill/>
+        </p:spPr>
+        <p:txBody>
+          <a:bodyPr wrap="square" lIns="0" tIns="0" rIns="0" bIns="0" rtlCol="0">
+            <a:noAutofit/>
+          </a:bodyPr>
           <a:lstStyle/>
           <a:p>
-            <a:r>
-              <a:rPr lang="en-US" dirty="0"/>
-              <a:t>Questions</a:t>
-            </a:r>
-          </a:p>
-        </p:txBody>
-      </p:sp>
-      <p:sp>
-        <p:nvSpPr>
-          <p:cNvPr id="3" name="Text Placeholder 2">
-            <a:extLst>
-              <a:ext uri="{FF2B5EF4-FFF2-40B4-BE49-F238E27FC236}">
-                <a16:creationId xmlns:a16="http://schemas.microsoft.com/office/drawing/2014/main" id="{3F777F8E-CCD2-E251-54C3-3AC716544F37}"/>
-              </a:ext>
-            </a:extLst>
-          </p:cNvPr>
-          <p:cNvSpPr>
-            <a:spLocks noGrp="1"/>
-          </p:cNvSpPr>
-          <p:nvPr>
-            <p:ph type="body" idx="1"/>
-          </p:nvPr>
-        </p:nvSpPr>
-        <p:spPr/>
-        <p:txBody>
-          <a:bodyPr/>
+            <a:pPr>
+              <a:lnSpc>
+                <a:spcPct val="95000"/>
+              </a:lnSpc>
+              <a:spcBef>
+                <a:spcPts val="1000"/>
+              </a:spcBef>
+              <a:buSzPct val="100000"/>
+            </a:pPr>
+            <a:r>
+              <a:rPr lang="en-US" sz="1700" dirty="0" err="1">
+                <a:latin typeface="Courier New" panose="02070309020205020404" pitchFamily="49" charset="0"/>
+                <a:cs typeface="Courier New" panose="02070309020205020404" pitchFamily="49" charset="0"/>
+              </a:rPr>
+              <a:t>username:password</a:t>
+            </a:r>
+            <a:endParaRPr lang="en-US" sz="1700" dirty="0">
+              <a:latin typeface="Courier New" panose="02070309020205020404" pitchFamily="49" charset="0"/>
+              <a:cs typeface="Courier New" panose="02070309020205020404" pitchFamily="49" charset="0"/>
+            </a:endParaRPr>
+          </a:p>
+        </p:txBody>
+      </p:sp>
+      <p:cxnSp>
+        <p:nvCxnSpPr>
+          <p:cNvPr id="12" name="Straight Arrow Connector 11">
+            <a:extLst>
+              <a:ext uri="{FF2B5EF4-FFF2-40B4-BE49-F238E27FC236}">
+                <a16:creationId xmlns:a16="http://schemas.microsoft.com/office/drawing/2014/main" id="{4C1A1A80-326A-D2C9-5E42-B9E51223CFEA}"/>
+              </a:ext>
+            </a:extLst>
+          </p:cNvPr>
+          <p:cNvCxnSpPr/>
+          <p:nvPr/>
+        </p:nvCxnSpPr>
+        <p:spPr>
+          <a:xfrm>
+            <a:off x="4064532" y="5337990"/>
+            <a:ext cx="612792" cy="0"/>
+          </a:xfrm>
+          <a:prstGeom prst="straightConnector1">
+            <a:avLst/>
+          </a:prstGeom>
+          <a:ln w="12700" cap="flat">
+            <a:miter/>
+            <a:tailEnd type="triangle"/>
+          </a:ln>
+        </p:spPr>
+        <p:style>
+          <a:lnRef idx="1">
+            <a:schemeClr val="accent1"/>
+          </a:lnRef>
+          <a:fillRef idx="0">
+            <a:schemeClr val="accent1"/>
+          </a:fillRef>
+          <a:effectRef idx="0">
+            <a:srgbClr val="000000"/>
+          </a:effectRef>
+          <a:fontRef idx="minor">
+            <a:srgbClr val="FFFFFF"/>
+          </a:fontRef>
+        </p:style>
+      </p:cxnSp>
+      <p:sp>
+        <p:nvSpPr>
+          <p:cNvPr id="13" name="TextBox 12">
+            <a:extLst>
+              <a:ext uri="{FF2B5EF4-FFF2-40B4-BE49-F238E27FC236}">
+                <a16:creationId xmlns:a16="http://schemas.microsoft.com/office/drawing/2014/main" id="{6A3171B8-B539-34F4-75C7-BC0670B088D4}"/>
+              </a:ext>
+            </a:extLst>
+          </p:cNvPr>
+          <p:cNvSpPr txBox="1"/>
+          <p:nvPr/>
+        </p:nvSpPr>
+        <p:spPr>
+          <a:xfrm>
+            <a:off x="4772275" y="5203941"/>
+            <a:ext cx="2341056" cy="339908"/>
+          </a:xfrm>
+          <a:prstGeom prst="rect">
+            <a:avLst/>
+          </a:prstGeom>
+          <a:noFill/>
+        </p:spPr>
+        <p:txBody>
+          <a:bodyPr wrap="square" lIns="0" tIns="0" rIns="0" bIns="0" rtlCol="0">
+            <a:noAutofit/>
+          </a:bodyPr>
           <a:lstStyle/>
           <a:p>
-            <a:endParaRPr lang="en-US"/>
-          </a:p>
-        </p:txBody>
-      </p:sp>
+            <a:pPr>
+              <a:lnSpc>
+                <a:spcPct val="95000"/>
+              </a:lnSpc>
+              <a:spcBef>
+                <a:spcPts val="1000"/>
+              </a:spcBef>
+              <a:buSzPct val="100000"/>
+            </a:pPr>
+            <a:r>
+              <a:rPr lang="en-US" sz="1700" dirty="0">
+                <a:latin typeface="Courier New" panose="02070309020205020404" pitchFamily="49" charset="0"/>
+                <a:cs typeface="Courier New" panose="02070309020205020404" pitchFamily="49" charset="0"/>
+              </a:rPr>
+              <a:t>Base64 encoded</a:t>
+            </a:r>
+          </a:p>
+        </p:txBody>
+      </p:sp>
+      <p:cxnSp>
+        <p:nvCxnSpPr>
+          <p:cNvPr id="14" name="Straight Arrow Connector 13">
+            <a:extLst>
+              <a:ext uri="{FF2B5EF4-FFF2-40B4-BE49-F238E27FC236}">
+                <a16:creationId xmlns:a16="http://schemas.microsoft.com/office/drawing/2014/main" id="{8A183196-FCA7-75BC-CBE3-0253E633D2D3}"/>
+              </a:ext>
+            </a:extLst>
+          </p:cNvPr>
+          <p:cNvCxnSpPr>
+            <a:cxnSpLocks/>
+          </p:cNvCxnSpPr>
+          <p:nvPr/>
+        </p:nvCxnSpPr>
+        <p:spPr>
+          <a:xfrm flipV="1">
+            <a:off x="6754273" y="3992720"/>
+            <a:ext cx="153995" cy="1339685"/>
+          </a:xfrm>
+          <a:prstGeom prst="straightConnector1">
+            <a:avLst/>
+          </a:prstGeom>
+          <a:ln w="12700" cap="flat">
+            <a:miter/>
+            <a:tailEnd type="triangle"/>
+          </a:ln>
+        </p:spPr>
+        <p:style>
+          <a:lnRef idx="1">
+            <a:schemeClr val="accent1"/>
+          </a:lnRef>
+          <a:fillRef idx="0">
+            <a:schemeClr val="accent1"/>
+          </a:fillRef>
+          <a:effectRef idx="0">
+            <a:srgbClr val="000000"/>
+          </a:effectRef>
+          <a:fontRef idx="minor">
+            <a:srgbClr val="FFFFFF"/>
+          </a:fontRef>
+        </p:style>
+      </p:cxnSp>
     </p:spTree>
     <p:extLst>
       <p:ext uri="{BB962C8B-B14F-4D97-AF65-F5344CB8AC3E}">
-        <p14:creationId xmlns:p14="http://schemas.microsoft.com/office/powerpoint/2010/main" val="3276679044"/>
+        <p14:creationId xmlns:p14="http://schemas.microsoft.com/office/powerpoint/2010/main" val="4047409845"/>
+      </p:ext>
+    </p:extLst>
+  </p:cSld>
+  <p:clrMapOvr>
+    <a:masterClrMapping/>
+  </p:clrMapOvr>
+  <p:timing>
+    <p:tnLst>
+      <p:par>
+        <p:cTn id="1" dur="indefinite" restart="never" nodeType="tmRoot">
+          <p:childTnLst>
+            <p:seq concurrent="1" nextAc="seek">
+              <p:cTn id="2" dur="indefinite" nodeType="mainSeq">
+                <p:childTnLst>
+                  <p:par>
+                    <p:cTn id="3" fill="hold">
+                      <p:stCondLst>
+                        <p:cond delay="indefinite"/>
+                      </p:stCondLst>
+                      <p:childTnLst>
+                        <p:par>
+                          <p:cTn id="4" fill="hold">
+                            <p:stCondLst>
+                              <p:cond delay="0"/>
+                            </p:stCondLst>
+                            <p:childTnLst>
+                              <p:par>
+                                <p:cTn id="5" presetID="1" presetClass="entr" presetSubtype="0" fill="hold" grpId="0" nodeType="clickEffect">
+                                  <p:stCondLst>
+                                    <p:cond delay="0"/>
+                                  </p:stCondLst>
+                                  <p:childTnLst>
+                                    <p:set>
+                                      <p:cBhvr>
+                                        <p:cTn id="6" dur="1" fill="hold">
+                                          <p:stCondLst>
+                                            <p:cond delay="0"/>
+                                          </p:stCondLst>
+                                        </p:cTn>
+                                        <p:tgtEl>
+                                          <p:spTgt spid="10"/>
+                                        </p:tgtEl>
+                                        <p:attrNameLst>
+                                          <p:attrName>style.visibility</p:attrName>
+                                        </p:attrNameLst>
+                                      </p:cBhvr>
+                                      <p:to>
+                                        <p:strVal val="visible"/>
+                                      </p:to>
+                                    </p:set>
+                                  </p:childTnLst>
+                                </p:cTn>
+                              </p:par>
+                              <p:par>
+                                <p:cTn id="7" presetID="1" presetClass="entr" presetSubtype="0" fill="hold" nodeType="withEffect">
+                                  <p:stCondLst>
+                                    <p:cond delay="0"/>
+                                  </p:stCondLst>
+                                  <p:childTnLst>
+                                    <p:set>
+                                      <p:cBhvr>
+                                        <p:cTn id="8" dur="1" fill="hold">
+                                          <p:stCondLst>
+                                            <p:cond delay="0"/>
+                                          </p:stCondLst>
+                                        </p:cTn>
+                                        <p:tgtEl>
+                                          <p:spTgt spid="12"/>
+                                        </p:tgtEl>
+                                        <p:attrNameLst>
+                                          <p:attrName>style.visibility</p:attrName>
+                                        </p:attrNameLst>
+                                      </p:cBhvr>
+                                      <p:to>
+                                        <p:strVal val="visible"/>
+                                      </p:to>
+                                    </p:set>
+                                  </p:childTnLst>
+                                </p:cTn>
+                              </p:par>
+                              <p:par>
+                                <p:cTn id="9" presetID="1" presetClass="entr" presetSubtype="0" fill="hold" grpId="0" nodeType="withEffect">
+                                  <p:stCondLst>
+                                    <p:cond delay="0"/>
+                                  </p:stCondLst>
+                                  <p:childTnLst>
+                                    <p:set>
+                                      <p:cBhvr>
+                                        <p:cTn id="10" dur="1" fill="hold">
+                                          <p:stCondLst>
+                                            <p:cond delay="0"/>
+                                          </p:stCondLst>
+                                        </p:cTn>
+                                        <p:tgtEl>
+                                          <p:spTgt spid="13"/>
+                                        </p:tgtEl>
+                                        <p:attrNameLst>
+                                          <p:attrName>style.visibility</p:attrName>
+                                        </p:attrNameLst>
+                                      </p:cBhvr>
+                                      <p:to>
+                                        <p:strVal val="visible"/>
+                                      </p:to>
+                                    </p:set>
+                                  </p:childTnLst>
+                                </p:cTn>
+                              </p:par>
+                              <p:par>
+                                <p:cTn id="11" presetID="1" presetClass="entr" presetSubtype="0" fill="hold" nodeType="withEffect">
+                                  <p:stCondLst>
+                                    <p:cond delay="0"/>
+                                  </p:stCondLst>
+                                  <p:childTnLst>
+                                    <p:set>
+                                      <p:cBhvr>
+                                        <p:cTn id="12" dur="1" fill="hold">
+                                          <p:stCondLst>
+                                            <p:cond delay="0"/>
+                                          </p:stCondLst>
+                                        </p:cTn>
+                                        <p:tgtEl>
+                                          <p:spTgt spid="14"/>
+                                        </p:tgtEl>
+                                        <p:attrNameLst>
+                                          <p:attrName>style.visibility</p:attrName>
+                                        </p:attrNameLst>
+                                      </p:cBhvr>
+                                      <p:to>
+                                        <p:strVal val="visible"/>
+                                      </p:to>
+                                    </p:set>
+                                  </p:childTnLst>
+                                </p:cTn>
+                              </p:par>
+                            </p:childTnLst>
+                          </p:cTn>
+                        </p:par>
+                      </p:childTnLst>
+                    </p:cTn>
+                  </p:par>
+                </p:childTnLst>
+              </p:cTn>
+              <p:prevCondLst>
+                <p:cond evt="onPrev" delay="0">
+                  <p:tgtEl>
+                    <p:sldTgt/>
+                  </p:tgtEl>
+                </p:cond>
+              </p:prevCondLst>
+              <p:nextCondLst>
+                <p:cond evt="onNext" delay="0">
+                  <p:tgtEl>
+                    <p:sldTgt/>
+                  </p:tgtEl>
+                </p:cond>
+              </p:nextCondLst>
+            </p:seq>
+          </p:childTnLst>
+        </p:cTn>
+      </p:par>
+    </p:tnLst>
+    <p:bldLst>
+      <p:bldP spid="10" grpId="0"/>
+      <p:bldP spid="13" grpId="0"/>
+    </p:bldLst>
+  </p:timing>
+</p:sld>
+</file>
+
+<file path=ppt/slides/slide18.xml><?xml version="1.0" encoding="utf-8"?>
+<p:sld xmlns:a="http://schemas.openxmlformats.org/drawingml/2006/main" xmlns:r="http://schemas.openxmlformats.org/officeDocument/2006/relationships" xmlns:p="http://schemas.openxmlformats.org/presentationml/2006/main">
+  <p:cSld>
+    <p:spTree>
+      <p:nvGrpSpPr>
+        <p:cNvPr id="1" name=""/>
+        <p:cNvGrpSpPr/>
+        <p:nvPr/>
+      </p:nvGrpSpPr>
+      <p:grpSpPr>
+        <a:xfrm>
+          <a:off x="0" y="0"/>
+          <a:ext cx="0" cy="0"/>
+          <a:chOff x="0" y="0"/>
+          <a:chExt cx="0" cy="0"/>
+        </a:xfrm>
+      </p:grpSpPr>
+      <p:sp>
+        <p:nvSpPr>
+          <p:cNvPr id="2" name="Title 1">
+            <a:extLst>
+              <a:ext uri="{FF2B5EF4-FFF2-40B4-BE49-F238E27FC236}">
+                <a16:creationId xmlns:a16="http://schemas.microsoft.com/office/drawing/2014/main" id="{DEAA1446-ADB3-2F38-B72B-4030E81056C2}"/>
+              </a:ext>
+            </a:extLst>
+          </p:cNvPr>
+          <p:cNvSpPr>
+            <a:spLocks noGrp="1"/>
+          </p:cNvSpPr>
+          <p:nvPr>
+            <p:ph type="title"/>
+          </p:nvPr>
+        </p:nvSpPr>
+        <p:spPr/>
+        <p:txBody>
+          <a:bodyPr/>
+          <a:lstStyle/>
+          <a:p>
+            <a:r>
+              <a:rPr lang="en-US" dirty="0"/>
+              <a:t>Key/Token Authentication</a:t>
+            </a:r>
+          </a:p>
+        </p:txBody>
+      </p:sp>
+      <p:pic>
+        <p:nvPicPr>
+          <p:cNvPr id="6" name="Content Placeholder 5" descr="https://storage.googleapis.com/gweb-cloudblog-publish/images/2_REST_API_authentication.max-600x600.jpg">
+            <a:extLst>
+              <a:ext uri="{FF2B5EF4-FFF2-40B4-BE49-F238E27FC236}">
+                <a16:creationId xmlns:a16="http://schemas.microsoft.com/office/drawing/2014/main" id="{F7E46912-BD70-B243-81D7-FBBB4A84C52A}"/>
+              </a:ext>
+            </a:extLst>
+          </p:cNvPr>
+          <p:cNvPicPr>
+            <a:picLocks noGrp="1" noChangeAspect="1"/>
+          </p:cNvPicPr>
+          <p:nvPr>
+            <p:ph idx="1"/>
+          </p:nvPr>
+        </p:nvPicPr>
+        <p:blipFill>
+          <a:blip r:embed="rId3"/>
+          <a:srcRect t="17639"/>
+          <a:stretch>
+            <a:fillRect/>
+          </a:stretch>
+        </p:blipFill>
+        <p:spPr>
+          <a:xfrm>
+            <a:off x="1789355" y="1505475"/>
+            <a:ext cx="8910239" cy="4354235"/>
+          </a:xfrm>
+          <a:prstGeom prst="rect">
+            <a:avLst/>
+          </a:prstGeom>
+        </p:spPr>
+      </p:pic>
+      <p:sp>
+        <p:nvSpPr>
+          <p:cNvPr id="4" name="Date Placeholder 3">
+            <a:extLst>
+              <a:ext uri="{FF2B5EF4-FFF2-40B4-BE49-F238E27FC236}">
+                <a16:creationId xmlns:a16="http://schemas.microsoft.com/office/drawing/2014/main" id="{BDE9BF91-2812-2A4F-A013-2930309161C1}"/>
+              </a:ext>
+            </a:extLst>
+          </p:cNvPr>
+          <p:cNvSpPr>
+            <a:spLocks noGrp="1"/>
+          </p:cNvSpPr>
+          <p:nvPr>
+            <p:ph type="dt" sz="half" idx="10"/>
+          </p:nvPr>
+        </p:nvSpPr>
+        <p:spPr/>
+        <p:txBody>
+          <a:bodyPr/>
+          <a:lstStyle/>
+          <a:p>
+            <a:fld id="{AD622D1A-DF83-41A8-85FF-04D90BF831D3}" type="datetime3">
+              <a:rPr lang="en-US" smtClean="0"/>
+              <a:t>23 June 2026</a:t>
+            </a:fld>
+            <a:endParaRPr lang="en-US"/>
+          </a:p>
+        </p:txBody>
+      </p:sp>
+      <p:sp>
+        <p:nvSpPr>
+          <p:cNvPr id="5" name="Slide Number Placeholder 4">
+            <a:extLst>
+              <a:ext uri="{FF2B5EF4-FFF2-40B4-BE49-F238E27FC236}">
+                <a16:creationId xmlns:a16="http://schemas.microsoft.com/office/drawing/2014/main" id="{1DA38EAD-0C32-AB1B-3764-BBA95303CBC4}"/>
+              </a:ext>
+            </a:extLst>
+          </p:cNvPr>
+          <p:cNvSpPr>
+            <a:spLocks noGrp="1"/>
+          </p:cNvSpPr>
+          <p:nvPr>
+            <p:ph type="sldNum" sz="quarter" idx="11"/>
+          </p:nvPr>
+        </p:nvSpPr>
+        <p:spPr/>
+        <p:txBody>
+          <a:bodyPr/>
+          <a:lstStyle/>
+          <a:p>
+            <a:fld id="{64E5BE4B-2FBF-4174-9E62-85FAD1CB43A6}" type="slidenum">
+              <a:rPr lang="en-US" smtClean="0"/>
+              <a:pPr/>
+              <a:t>18</a:t>
+            </a:fld>
+            <a:endParaRPr lang="en-US"/>
+          </a:p>
+        </p:txBody>
+      </p:sp>
+    </p:spTree>
+    <p:extLst>
+      <p:ext uri="{BB962C8B-B14F-4D97-AF65-F5344CB8AC3E}">
+        <p14:creationId xmlns:p14="http://schemas.microsoft.com/office/powerpoint/2010/main" val="3062422179"/>
+      </p:ext>
+    </p:extLst>
+  </p:cSld>
+  <p:clrMapOvr>
+    <a:masterClrMapping/>
+  </p:clrMapOvr>
+</p:sld>
+</file>
+
+<file path=ppt/slides/slide19.xml><?xml version="1.0" encoding="utf-8"?>
+<p:sld xmlns:a="http://schemas.openxmlformats.org/drawingml/2006/main" xmlns:r="http://schemas.openxmlformats.org/officeDocument/2006/relationships" xmlns:p="http://schemas.openxmlformats.org/presentationml/2006/main">
+  <p:cSld>
+    <p:spTree>
+      <p:nvGrpSpPr>
+        <p:cNvPr id="1" name=""/>
+        <p:cNvGrpSpPr/>
+        <p:nvPr/>
+      </p:nvGrpSpPr>
+      <p:grpSpPr>
+        <a:xfrm>
+          <a:off x="0" y="0"/>
+          <a:ext cx="0" cy="0"/>
+          <a:chOff x="0" y="0"/>
+          <a:chExt cx="0" cy="0"/>
+        </a:xfrm>
+      </p:grpSpPr>
+      <p:sp>
+        <p:nvSpPr>
+          <p:cNvPr id="2" name="Title 1">
+            <a:extLst>
+              <a:ext uri="{FF2B5EF4-FFF2-40B4-BE49-F238E27FC236}">
+                <a16:creationId xmlns:a16="http://schemas.microsoft.com/office/drawing/2014/main" id="{30099FD1-804C-6A0E-D8D3-593A8FFE3A2D}"/>
+              </a:ext>
+            </a:extLst>
+          </p:cNvPr>
+          <p:cNvSpPr>
+            <a:spLocks noGrp="1"/>
+          </p:cNvSpPr>
+          <p:nvPr>
+            <p:ph type="title"/>
+          </p:nvPr>
+        </p:nvSpPr>
+        <p:spPr/>
+        <p:txBody>
+          <a:bodyPr/>
+          <a:lstStyle/>
+          <a:p>
+            <a:r>
+              <a:rPr lang="en-US" dirty="0"/>
+              <a:t>Session Cookies</a:t>
+            </a:r>
+          </a:p>
+        </p:txBody>
+      </p:sp>
+      <p:pic>
+        <p:nvPicPr>
+          <p:cNvPr id="6" name="Content Placeholder 5" descr="Mastering Modern Authentication: Cookies, Sessions, JWT, and PASETO">
+            <a:extLst>
+              <a:ext uri="{FF2B5EF4-FFF2-40B4-BE49-F238E27FC236}">
+                <a16:creationId xmlns:a16="http://schemas.microsoft.com/office/drawing/2014/main" id="{D1F12538-1EA7-C8BA-73C7-008D873697AC}"/>
+              </a:ext>
+            </a:extLst>
+          </p:cNvPr>
+          <p:cNvPicPr>
+            <a:picLocks noGrp="1" noChangeAspect="1"/>
+          </p:cNvPicPr>
+          <p:nvPr>
+            <p:ph idx="1"/>
+          </p:nvPr>
+        </p:nvPicPr>
+        <p:blipFill>
+          <a:blip r:embed="rId3"/>
+          <a:stretch>
+            <a:fillRect/>
+          </a:stretch>
+        </p:blipFill>
+        <p:spPr>
+          <a:xfrm>
+            <a:off x="2337265" y="1379150"/>
+            <a:ext cx="7358720" cy="4828190"/>
+          </a:xfrm>
+          <a:prstGeom prst="rect">
+            <a:avLst/>
+          </a:prstGeom>
+        </p:spPr>
+      </p:pic>
+      <p:sp>
+        <p:nvSpPr>
+          <p:cNvPr id="4" name="Date Placeholder 3">
+            <a:extLst>
+              <a:ext uri="{FF2B5EF4-FFF2-40B4-BE49-F238E27FC236}">
+                <a16:creationId xmlns:a16="http://schemas.microsoft.com/office/drawing/2014/main" id="{3C69615D-C4A4-B60F-7BC5-2C56EA3DF0DF}"/>
+              </a:ext>
+            </a:extLst>
+          </p:cNvPr>
+          <p:cNvSpPr>
+            <a:spLocks noGrp="1"/>
+          </p:cNvSpPr>
+          <p:nvPr>
+            <p:ph type="dt" sz="half" idx="10"/>
+          </p:nvPr>
+        </p:nvSpPr>
+        <p:spPr/>
+        <p:txBody>
+          <a:bodyPr/>
+          <a:lstStyle/>
+          <a:p>
+            <a:fld id="{AD622D1A-DF83-41A8-85FF-04D90BF831D3}" type="datetime3">
+              <a:rPr lang="en-US" smtClean="0"/>
+              <a:t>23 June 2026</a:t>
+            </a:fld>
+            <a:endParaRPr lang="en-US"/>
+          </a:p>
+        </p:txBody>
+      </p:sp>
+      <p:sp>
+        <p:nvSpPr>
+          <p:cNvPr id="5" name="Slide Number Placeholder 4">
+            <a:extLst>
+              <a:ext uri="{FF2B5EF4-FFF2-40B4-BE49-F238E27FC236}">
+                <a16:creationId xmlns:a16="http://schemas.microsoft.com/office/drawing/2014/main" id="{87FD5202-6560-6919-5B0C-2C5C7D002792}"/>
+              </a:ext>
+            </a:extLst>
+          </p:cNvPr>
+          <p:cNvSpPr>
+            <a:spLocks noGrp="1"/>
+          </p:cNvSpPr>
+          <p:nvPr>
+            <p:ph type="sldNum" sz="quarter" idx="11"/>
+          </p:nvPr>
+        </p:nvSpPr>
+        <p:spPr/>
+        <p:txBody>
+          <a:bodyPr/>
+          <a:lstStyle/>
+          <a:p>
+            <a:fld id="{64E5BE4B-2FBF-4174-9E62-85FAD1CB43A6}" type="slidenum">
+              <a:rPr lang="en-US" smtClean="0"/>
+              <a:pPr/>
+              <a:t>19</a:t>
+            </a:fld>
+            <a:endParaRPr lang="en-US"/>
+          </a:p>
+        </p:txBody>
+      </p:sp>
+    </p:spTree>
+    <p:extLst>
+      <p:ext uri="{BB962C8B-B14F-4D97-AF65-F5344CB8AC3E}">
+        <p14:creationId xmlns:p14="http://schemas.microsoft.com/office/powerpoint/2010/main" val="1365411777"/>
       </p:ext>
     </p:extLst>
   </p:cSld>
@@ -25529,7 +28049,10 @@
             </a:r>
           </a:p>
           <a:p>
-            <a:endParaRPr lang="en-US" dirty="0"/>
+            <a:r>
+              <a:rPr lang="en-US" dirty="0"/>
+              <a:t>"The language of the web"</a:t>
+            </a:r>
           </a:p>
           <a:p>
             <a:endParaRPr lang="en-US" dirty="0"/>
@@ -25549,6 +28072,590 @@
     <p:extLst>
       <p:ext uri="{BB962C8B-B14F-4D97-AF65-F5344CB8AC3E}">
         <p14:creationId xmlns:p14="http://schemas.microsoft.com/office/powerpoint/2010/main" val="3708550872"/>
+      </p:ext>
+    </p:extLst>
+  </p:cSld>
+  <p:clrMapOvr>
+    <a:masterClrMapping/>
+  </p:clrMapOvr>
+</p:sld>
+</file>
+
+<file path=ppt/slides/slide20.xml><?xml version="1.0" encoding="utf-8"?>
+<p:sld xmlns:a="http://schemas.openxmlformats.org/drawingml/2006/main" xmlns:r="http://schemas.openxmlformats.org/officeDocument/2006/relationships" xmlns:p="http://schemas.openxmlformats.org/presentationml/2006/main">
+  <p:cSld>
+    <p:spTree>
+      <p:nvGrpSpPr>
+        <p:cNvPr id="1" name=""/>
+        <p:cNvGrpSpPr/>
+        <p:nvPr/>
+      </p:nvGrpSpPr>
+      <p:grpSpPr>
+        <a:xfrm>
+          <a:off x="0" y="0"/>
+          <a:ext cx="0" cy="0"/>
+          <a:chOff x="0" y="0"/>
+          <a:chExt cx="0" cy="0"/>
+        </a:xfrm>
+      </p:grpSpPr>
+      <p:sp>
+        <p:nvSpPr>
+          <p:cNvPr id="2" name="Title 1">
+            <a:extLst>
+              <a:ext uri="{FF2B5EF4-FFF2-40B4-BE49-F238E27FC236}">
+                <a16:creationId xmlns:a16="http://schemas.microsoft.com/office/drawing/2014/main" id="{245A1E55-6DB6-9C27-E006-65A7F8B45FD1}"/>
+              </a:ext>
+            </a:extLst>
+          </p:cNvPr>
+          <p:cNvSpPr>
+            <a:spLocks noGrp="1"/>
+          </p:cNvSpPr>
+          <p:nvPr>
+            <p:ph type="title"/>
+          </p:nvPr>
+        </p:nvSpPr>
+        <p:spPr/>
+        <p:txBody>
+          <a:bodyPr/>
+          <a:lstStyle/>
+          <a:p>
+            <a:r>
+              <a:rPr lang="en-US" dirty="0"/>
+              <a:t>OAUTH</a:t>
+            </a:r>
+          </a:p>
+        </p:txBody>
+      </p:sp>
+      <p:sp>
+        <p:nvSpPr>
+          <p:cNvPr id="4" name="Date Placeholder 3">
+            <a:extLst>
+              <a:ext uri="{FF2B5EF4-FFF2-40B4-BE49-F238E27FC236}">
+                <a16:creationId xmlns:a16="http://schemas.microsoft.com/office/drawing/2014/main" id="{6D422CD3-B82C-4C99-18CA-0A04C99FAB2C}"/>
+              </a:ext>
+            </a:extLst>
+          </p:cNvPr>
+          <p:cNvSpPr>
+            <a:spLocks noGrp="1"/>
+          </p:cNvSpPr>
+          <p:nvPr>
+            <p:ph type="dt" sz="half" idx="10"/>
+          </p:nvPr>
+        </p:nvSpPr>
+        <p:spPr/>
+        <p:txBody>
+          <a:bodyPr/>
+          <a:lstStyle/>
+          <a:p>
+            <a:fld id="{AD622D1A-DF83-41A8-85FF-04D90BF831D3}" type="datetime3">
+              <a:rPr lang="en-US" smtClean="0"/>
+              <a:t>23 June 2026</a:t>
+            </a:fld>
+            <a:endParaRPr lang="en-US"/>
+          </a:p>
+        </p:txBody>
+      </p:sp>
+      <p:sp>
+        <p:nvSpPr>
+          <p:cNvPr id="5" name="Slide Number Placeholder 4">
+            <a:extLst>
+              <a:ext uri="{FF2B5EF4-FFF2-40B4-BE49-F238E27FC236}">
+                <a16:creationId xmlns:a16="http://schemas.microsoft.com/office/drawing/2014/main" id="{55EC3B39-E1C7-7D98-4286-8457DBC26678}"/>
+              </a:ext>
+            </a:extLst>
+          </p:cNvPr>
+          <p:cNvSpPr>
+            <a:spLocks noGrp="1"/>
+          </p:cNvSpPr>
+          <p:nvPr>
+            <p:ph type="sldNum" sz="quarter" idx="11"/>
+          </p:nvPr>
+        </p:nvSpPr>
+        <p:spPr/>
+        <p:txBody>
+          <a:bodyPr/>
+          <a:lstStyle/>
+          <a:p>
+            <a:fld id="{64E5BE4B-2FBF-4174-9E62-85FAD1CB43A6}" type="slidenum">
+              <a:rPr lang="en-US" smtClean="0"/>
+              <a:pPr/>
+              <a:t>20</a:t>
+            </a:fld>
+            <a:endParaRPr lang="en-US"/>
+          </a:p>
+        </p:txBody>
+      </p:sp>
+      <p:pic>
+        <p:nvPicPr>
+          <p:cNvPr id="9" name="Content Placeholder 8" descr="A .NET Developer's Complete Guide to Choose Right Authentication: From ...">
+            <a:extLst>
+              <a:ext uri="{FF2B5EF4-FFF2-40B4-BE49-F238E27FC236}">
+                <a16:creationId xmlns:a16="http://schemas.microsoft.com/office/drawing/2014/main" id="{B6CC2724-4C1C-1C34-B772-14618D6BE1E0}"/>
+              </a:ext>
+            </a:extLst>
+          </p:cNvPr>
+          <p:cNvPicPr>
+            <a:picLocks noGrp="1" noChangeAspect="1"/>
+          </p:cNvPicPr>
+          <p:nvPr>
+            <p:ph idx="1"/>
+          </p:nvPr>
+        </p:nvPicPr>
+        <p:blipFill>
+          <a:blip r:embed="rId3"/>
+          <a:stretch>
+            <a:fillRect/>
+          </a:stretch>
+        </p:blipFill>
+        <p:spPr>
+          <a:xfrm>
+            <a:off x="1847216" y="1042463"/>
+            <a:ext cx="8497568" cy="5665045"/>
+          </a:xfrm>
+          <a:prstGeom prst="rect">
+            <a:avLst/>
+          </a:prstGeom>
+        </p:spPr>
+      </p:pic>
+    </p:spTree>
+    <p:extLst>
+      <p:ext uri="{BB962C8B-B14F-4D97-AF65-F5344CB8AC3E}">
+        <p14:creationId xmlns:p14="http://schemas.microsoft.com/office/powerpoint/2010/main" val="3140410399"/>
+      </p:ext>
+    </p:extLst>
+  </p:cSld>
+  <p:clrMapOvr>
+    <a:masterClrMapping/>
+  </p:clrMapOvr>
+</p:sld>
+</file>
+
+<file path=ppt/slides/slide21.xml><?xml version="1.0" encoding="utf-8"?>
+<p:sld xmlns:a="http://schemas.openxmlformats.org/drawingml/2006/main" xmlns:r="http://schemas.openxmlformats.org/officeDocument/2006/relationships" xmlns:p="http://schemas.openxmlformats.org/presentationml/2006/main">
+  <p:cSld>
+    <p:spTree>
+      <p:nvGrpSpPr>
+        <p:cNvPr id="1" name=""/>
+        <p:cNvGrpSpPr/>
+        <p:nvPr/>
+      </p:nvGrpSpPr>
+      <p:grpSpPr>
+        <a:xfrm>
+          <a:off x="0" y="0"/>
+          <a:ext cx="0" cy="0"/>
+          <a:chOff x="0" y="0"/>
+          <a:chExt cx="0" cy="0"/>
+        </a:xfrm>
+      </p:grpSpPr>
+      <p:sp>
+        <p:nvSpPr>
+          <p:cNvPr id="2" name="Title 1">
+            <a:extLst>
+              <a:ext uri="{FF2B5EF4-FFF2-40B4-BE49-F238E27FC236}">
+                <a16:creationId xmlns:a16="http://schemas.microsoft.com/office/drawing/2014/main" id="{6933EABF-D295-BDCC-9EFB-883A8886466A}"/>
+              </a:ext>
+            </a:extLst>
+          </p:cNvPr>
+          <p:cNvSpPr>
+            <a:spLocks noGrp="1"/>
+          </p:cNvSpPr>
+          <p:nvPr>
+            <p:ph type="title"/>
+          </p:nvPr>
+        </p:nvSpPr>
+        <p:spPr/>
+        <p:txBody>
+          <a:bodyPr/>
+          <a:lstStyle/>
+          <a:p>
+            <a:r>
+              <a:rPr lang="en-US" dirty="0"/>
+              <a:t>In General…</a:t>
+            </a:r>
+          </a:p>
+        </p:txBody>
+      </p:sp>
+      <p:sp>
+        <p:nvSpPr>
+          <p:cNvPr id="3" name="Content Placeholder 2">
+            <a:extLst>
+              <a:ext uri="{FF2B5EF4-FFF2-40B4-BE49-F238E27FC236}">
+                <a16:creationId xmlns:a16="http://schemas.microsoft.com/office/drawing/2014/main" id="{A662615F-5293-3382-FE23-D26BD80FDC63}"/>
+              </a:ext>
+            </a:extLst>
+          </p:cNvPr>
+          <p:cNvSpPr>
+            <a:spLocks noGrp="1"/>
+          </p:cNvSpPr>
+          <p:nvPr>
+            <p:ph idx="1"/>
+          </p:nvPr>
+        </p:nvSpPr>
+        <p:spPr/>
+        <p:txBody>
+          <a:bodyPr/>
+          <a:lstStyle/>
+          <a:p>
+            <a:r>
+              <a:rPr lang="en-US" dirty="0"/>
+              <a:t>How long does the token live?</a:t>
+            </a:r>
+          </a:p>
+          <a:p>
+            <a:r>
+              <a:rPr lang="en-US" dirty="0"/>
+              <a:t>Who generates the token?</a:t>
+            </a:r>
+          </a:p>
+          <a:p>
+            <a:r>
+              <a:rPr lang="en-US" dirty="0"/>
+              <a:t>Who maintains (revokes) the token?</a:t>
+            </a:r>
+          </a:p>
+          <a:p>
+            <a:r>
+              <a:rPr lang="en-US" dirty="0"/>
+              <a:t>What resource is the token for?</a:t>
+            </a:r>
+          </a:p>
+          <a:p>
+            <a:r>
+              <a:rPr lang="en-US" dirty="0"/>
+              <a:t>Is the token stateless or stateful?</a:t>
+            </a:r>
+          </a:p>
+        </p:txBody>
+      </p:sp>
+      <p:sp>
+        <p:nvSpPr>
+          <p:cNvPr id="4" name="Date Placeholder 3">
+            <a:extLst>
+              <a:ext uri="{FF2B5EF4-FFF2-40B4-BE49-F238E27FC236}">
+                <a16:creationId xmlns:a16="http://schemas.microsoft.com/office/drawing/2014/main" id="{EC2B2493-A509-7F39-10EE-1F98483E5DE9}"/>
+              </a:ext>
+            </a:extLst>
+          </p:cNvPr>
+          <p:cNvSpPr>
+            <a:spLocks noGrp="1"/>
+          </p:cNvSpPr>
+          <p:nvPr>
+            <p:ph type="dt" sz="half" idx="10"/>
+          </p:nvPr>
+        </p:nvSpPr>
+        <p:spPr/>
+        <p:txBody>
+          <a:bodyPr/>
+          <a:lstStyle/>
+          <a:p>
+            <a:fld id="{AD622D1A-DF83-41A8-85FF-04D90BF831D3}" type="datetime3">
+              <a:rPr lang="en-US" smtClean="0"/>
+              <a:t>23 June 2026</a:t>
+            </a:fld>
+            <a:endParaRPr lang="en-US"/>
+          </a:p>
+        </p:txBody>
+      </p:sp>
+      <p:sp>
+        <p:nvSpPr>
+          <p:cNvPr id="5" name="Slide Number Placeholder 4">
+            <a:extLst>
+              <a:ext uri="{FF2B5EF4-FFF2-40B4-BE49-F238E27FC236}">
+                <a16:creationId xmlns:a16="http://schemas.microsoft.com/office/drawing/2014/main" id="{7AAEBBA9-84CB-B70E-1672-870FF72A108D}"/>
+              </a:ext>
+            </a:extLst>
+          </p:cNvPr>
+          <p:cNvSpPr>
+            <a:spLocks noGrp="1"/>
+          </p:cNvSpPr>
+          <p:nvPr>
+            <p:ph type="sldNum" sz="quarter" idx="11"/>
+          </p:nvPr>
+        </p:nvSpPr>
+        <p:spPr/>
+        <p:txBody>
+          <a:bodyPr/>
+          <a:lstStyle/>
+          <a:p>
+            <a:fld id="{64E5BE4B-2FBF-4174-9E62-85FAD1CB43A6}" type="slidenum">
+              <a:rPr lang="en-US" smtClean="0"/>
+              <a:pPr/>
+              <a:t>21</a:t>
+            </a:fld>
+            <a:endParaRPr lang="en-US"/>
+          </a:p>
+        </p:txBody>
+      </p:sp>
+      <p:pic>
+        <p:nvPicPr>
+          <p:cNvPr id="6" name="Content Placeholder 5" descr="Beginner’s Guide to FastAPI &amp; OpenAI ChatGPT API Integration | by ...">
+            <a:extLst>
+              <a:ext uri="{FF2B5EF4-FFF2-40B4-BE49-F238E27FC236}">
+                <a16:creationId xmlns:a16="http://schemas.microsoft.com/office/drawing/2014/main" id="{9803990C-3BA7-D8C5-74DD-F46522B36FB8}"/>
+              </a:ext>
+            </a:extLst>
+          </p:cNvPr>
+          <p:cNvPicPr>
+            <a:picLocks noChangeAspect="1"/>
+          </p:cNvPicPr>
+          <p:nvPr/>
+        </p:nvPicPr>
+        <p:blipFill>
+          <a:blip r:embed="rId3"/>
+          <a:stretch>
+            <a:fillRect/>
+          </a:stretch>
+        </p:blipFill>
+        <p:spPr>
+          <a:xfrm>
+            <a:off x="6897756" y="122742"/>
+            <a:ext cx="5086550" cy="6612515"/>
+          </a:xfrm>
+          <a:prstGeom prst="rect">
+            <a:avLst/>
+          </a:prstGeom>
+        </p:spPr>
+      </p:pic>
+    </p:spTree>
+    <p:extLst>
+      <p:ext uri="{BB962C8B-B14F-4D97-AF65-F5344CB8AC3E}">
+        <p14:creationId xmlns:p14="http://schemas.microsoft.com/office/powerpoint/2010/main" val="3553619729"/>
+      </p:ext>
+    </p:extLst>
+  </p:cSld>
+  <p:clrMapOvr>
+    <a:masterClrMapping/>
+  </p:clrMapOvr>
+</p:sld>
+</file>
+
+<file path=ppt/slides/slide22.xml><?xml version="1.0" encoding="utf-8"?>
+<p:sld xmlns:a="http://schemas.openxmlformats.org/drawingml/2006/main" xmlns:r="http://schemas.openxmlformats.org/officeDocument/2006/relationships" xmlns:p="http://schemas.openxmlformats.org/presentationml/2006/main">
+  <p:cSld>
+    <p:spTree>
+      <p:nvGrpSpPr>
+        <p:cNvPr id="1" name="">
+          <a:extLst>
+            <a:ext uri="{FF2B5EF4-FFF2-40B4-BE49-F238E27FC236}">
+              <a16:creationId xmlns:a16="http://schemas.microsoft.com/office/drawing/2014/main" id="{E30E84A7-2742-3603-EF96-6ACA2AA57784}"/>
+            </a:ext>
+          </a:extLst>
+        </p:cNvPr>
+        <p:cNvGrpSpPr/>
+        <p:nvPr/>
+      </p:nvGrpSpPr>
+      <p:grpSpPr>
+        <a:xfrm>
+          <a:off x="0" y="0"/>
+          <a:ext cx="0" cy="0"/>
+          <a:chOff x="0" y="0"/>
+          <a:chExt cx="0" cy="0"/>
+        </a:xfrm>
+      </p:grpSpPr>
+      <p:sp>
+        <p:nvSpPr>
+          <p:cNvPr id="6" name="Title 5">
+            <a:extLst>
+              <a:ext uri="{FF2B5EF4-FFF2-40B4-BE49-F238E27FC236}">
+                <a16:creationId xmlns:a16="http://schemas.microsoft.com/office/drawing/2014/main" id="{FB369682-AF26-693A-D06B-56E66281B0ED}"/>
+              </a:ext>
+            </a:extLst>
+          </p:cNvPr>
+          <p:cNvSpPr>
+            <a:spLocks noGrp="1"/>
+          </p:cNvSpPr>
+          <p:nvPr>
+            <p:ph type="title"/>
+          </p:nvPr>
+        </p:nvSpPr>
+        <p:spPr/>
+        <p:txBody>
+          <a:bodyPr/>
+          <a:lstStyle/>
+          <a:p>
+            <a:r>
+              <a:rPr lang="en-US" dirty="0"/>
+              <a:t>Hands-On #2</a:t>
+            </a:r>
+          </a:p>
+        </p:txBody>
+      </p:sp>
+      <p:sp>
+        <p:nvSpPr>
+          <p:cNvPr id="7" name="Text Placeholder 6">
+            <a:extLst>
+              <a:ext uri="{FF2B5EF4-FFF2-40B4-BE49-F238E27FC236}">
+                <a16:creationId xmlns:a16="http://schemas.microsoft.com/office/drawing/2014/main" id="{058BFFDB-ED2B-DE78-8D46-A4B7CCA291FF}"/>
+              </a:ext>
+            </a:extLst>
+          </p:cNvPr>
+          <p:cNvSpPr>
+            <a:spLocks noGrp="1"/>
+          </p:cNvSpPr>
+          <p:nvPr>
+            <p:ph type="body" idx="1"/>
+          </p:nvPr>
+        </p:nvSpPr>
+        <p:spPr/>
+        <p:txBody>
+          <a:bodyPr/>
+          <a:lstStyle/>
+          <a:p>
+            <a:endParaRPr lang="en-US"/>
+          </a:p>
+        </p:txBody>
+      </p:sp>
+      <p:sp>
+        <p:nvSpPr>
+          <p:cNvPr id="4" name="Date Placeholder 3">
+            <a:extLst>
+              <a:ext uri="{FF2B5EF4-FFF2-40B4-BE49-F238E27FC236}">
+                <a16:creationId xmlns:a16="http://schemas.microsoft.com/office/drawing/2014/main" id="{6DBA612D-E650-2CDF-0E0D-68B80A16091B}"/>
+              </a:ext>
+            </a:extLst>
+          </p:cNvPr>
+          <p:cNvSpPr>
+            <a:spLocks noGrp="1"/>
+          </p:cNvSpPr>
+          <p:nvPr>
+            <p:ph type="dt" sz="half" idx="10"/>
+          </p:nvPr>
+        </p:nvSpPr>
+        <p:spPr/>
+        <p:txBody>
+          <a:bodyPr/>
+          <a:lstStyle/>
+          <a:p>
+            <a:fld id="{AD622D1A-DF83-41A8-85FF-04D90BF831D3}" type="datetime3">
+              <a:rPr lang="en-US" smtClean="0"/>
+              <a:t>23 June 2026</a:t>
+            </a:fld>
+            <a:endParaRPr lang="en-US"/>
+          </a:p>
+        </p:txBody>
+      </p:sp>
+      <p:sp>
+        <p:nvSpPr>
+          <p:cNvPr id="5" name="Slide Number Placeholder 4">
+            <a:extLst>
+              <a:ext uri="{FF2B5EF4-FFF2-40B4-BE49-F238E27FC236}">
+                <a16:creationId xmlns:a16="http://schemas.microsoft.com/office/drawing/2014/main" id="{31B5D87B-1F0B-4A03-F65E-DE12B209DB7E}"/>
+              </a:ext>
+            </a:extLst>
+          </p:cNvPr>
+          <p:cNvSpPr>
+            <a:spLocks noGrp="1"/>
+          </p:cNvSpPr>
+          <p:nvPr>
+            <p:ph type="sldNum" sz="quarter" idx="12"/>
+          </p:nvPr>
+        </p:nvSpPr>
+        <p:spPr/>
+        <p:txBody>
+          <a:bodyPr/>
+          <a:lstStyle/>
+          <a:p>
+            <a:fld id="{64E5BE4B-2FBF-4174-9E62-85FAD1CB43A6}" type="slidenum">
+              <a:rPr lang="en-US" smtClean="0"/>
+              <a:pPr/>
+              <a:t>22</a:t>
+            </a:fld>
+            <a:endParaRPr lang="en-US"/>
+          </a:p>
+        </p:txBody>
+      </p:sp>
+    </p:spTree>
+    <p:extLst>
+      <p:ext uri="{BB962C8B-B14F-4D97-AF65-F5344CB8AC3E}">
+        <p14:creationId xmlns:p14="http://schemas.microsoft.com/office/powerpoint/2010/main" val="4275923970"/>
+      </p:ext>
+    </p:extLst>
+  </p:cSld>
+  <p:clrMapOvr>
+    <a:masterClrMapping/>
+  </p:clrMapOvr>
+</p:sld>
+</file>
+
+<file path=ppt/slides/slide23.xml><?xml version="1.0" encoding="utf-8"?>
+<p:sld xmlns:a="http://schemas.openxmlformats.org/drawingml/2006/main" xmlns:r="http://schemas.openxmlformats.org/officeDocument/2006/relationships" xmlns:p="http://schemas.openxmlformats.org/presentationml/2006/main">
+  <p:cSld>
+    <p:spTree>
+      <p:nvGrpSpPr>
+        <p:cNvPr id="1" name=""/>
+        <p:cNvGrpSpPr/>
+        <p:nvPr/>
+      </p:nvGrpSpPr>
+      <p:grpSpPr>
+        <a:xfrm>
+          <a:off x="0" y="0"/>
+          <a:ext cx="0" cy="0"/>
+          <a:chOff x="0" y="0"/>
+          <a:chExt cx="0" cy="0"/>
+        </a:xfrm>
+      </p:grpSpPr>
+      <p:sp>
+        <p:nvSpPr>
+          <p:cNvPr id="5" name="Title 4">
+            <a:extLst>
+              <a:ext uri="{FF2B5EF4-FFF2-40B4-BE49-F238E27FC236}">
+                <a16:creationId xmlns:a16="http://schemas.microsoft.com/office/drawing/2014/main" id="{694CC769-791B-48CC-8DD8-3E436EE0B1A3}"/>
+              </a:ext>
+            </a:extLst>
+          </p:cNvPr>
+          <p:cNvSpPr>
+            <a:spLocks noGrp="1"/>
+          </p:cNvSpPr>
+          <p:nvPr>
+            <p:ph type="title"/>
+          </p:nvPr>
+        </p:nvSpPr>
+        <p:spPr>
+          <a:xfrm>
+            <a:off x="831850" y="1709738"/>
+            <a:ext cx="10515600" cy="2852737"/>
+          </a:xfrm>
+        </p:spPr>
+        <p:txBody>
+          <a:bodyPr/>
+          <a:lstStyle/>
+          <a:p>
+            <a:r>
+              <a:rPr lang="en-US" dirty="0"/>
+              <a:t>Questions</a:t>
+            </a:r>
+          </a:p>
+        </p:txBody>
+      </p:sp>
+      <p:sp>
+        <p:nvSpPr>
+          <p:cNvPr id="3" name="Text Placeholder 2">
+            <a:extLst>
+              <a:ext uri="{FF2B5EF4-FFF2-40B4-BE49-F238E27FC236}">
+                <a16:creationId xmlns:a16="http://schemas.microsoft.com/office/drawing/2014/main" id="{3F777F8E-CCD2-E251-54C3-3AC716544F37}"/>
+              </a:ext>
+            </a:extLst>
+          </p:cNvPr>
+          <p:cNvSpPr>
+            <a:spLocks noGrp="1"/>
+          </p:cNvSpPr>
+          <p:nvPr>
+            <p:ph type="body" idx="1"/>
+          </p:nvPr>
+        </p:nvSpPr>
+        <p:spPr/>
+        <p:txBody>
+          <a:bodyPr/>
+          <a:lstStyle/>
+          <a:p>
+            <a:endParaRPr lang="en-US"/>
+          </a:p>
+        </p:txBody>
+      </p:sp>
+    </p:spTree>
+    <p:extLst>
+      <p:ext uri="{BB962C8B-B14F-4D97-AF65-F5344CB8AC3E}">
+        <p14:creationId xmlns:p14="http://schemas.microsoft.com/office/powerpoint/2010/main" val="3276679044"/>
       </p:ext>
     </p:extLst>
   </p:cSld>
@@ -27457,7 +30564,7 @@
           <a:p>
             <a:fld id="{AD622D1A-DF83-41A8-85FF-04D90BF831D3}" type="datetime3">
               <a:rPr lang="en-US" smtClean="0"/>
-              <a:t>22 June 2026</a:t>
+              <a:t>23 June 2026</a:t>
             </a:fld>
             <a:endParaRPr lang="en-US"/>
           </a:p>
@@ -27620,7 +30727,7 @@
           <a:p>
             <a:fld id="{AD622D1A-DF83-41A8-85FF-04D90BF831D3}" type="datetime3">
               <a:rPr lang="en-US" smtClean="0"/>
-              <a:t>22 June 2026</a:t>
+              <a:t>23 June 2026</a:t>
             </a:fld>
             <a:endParaRPr lang="en-US"/>
           </a:p>

</xml_diff>